<commit_message>
feat: update project messaging, add green theme, and refine PPTX generation layout
</commit_message>
<xml_diff>
--- a/public/Apresentação - HUB LabDiv.pptx
+++ b/public/Apresentação - HUB LabDiv.pptx
@@ -1212,9 +1212,16 @@
   <p:cSld name="Slide 1">
     <p:bg>
       <p:bgPr>
-        <a:solidFill>
-          <a:srgbClr val="09090B"/>
-        </a:solidFill>
+        <a:blipFill dpi="0" rotWithShape="1">
+          <a:blip r:embed="rId1">
+            <a:lum/>
+          </a:blip>
+          <a:srcRect/>
+          <a:stretch>
+            <a:fillRect/>
+          </a:stretch>
+        </a:blipFill>
+        <a:effectLst/>
       </p:bgPr>
     </p:bg>
     <p:spTree>
@@ -1240,7 +1247,7 @@
         <p:spPr>
           <a:xfrm>
             <a:off x="0" y="0"/>
-            <a:ext cx="3044952" cy="91440"/>
+            <a:ext cx="3044952" cy="73152"/>
           </a:xfrm>
           <a:prstGeom prst="rect">
             <a:avLst/>
@@ -1260,7 +1267,7 @@
         <p:spPr>
           <a:xfrm>
             <a:off x="3044952" y="0"/>
-            <a:ext cx="3044952" cy="91440"/>
+            <a:ext cx="3044952" cy="73152"/>
           </a:xfrm>
           <a:prstGeom prst="rect">
             <a:avLst/>
@@ -1280,7 +1287,7 @@
         <p:spPr>
           <a:xfrm>
             <a:off x="6089904" y="0"/>
-            <a:ext cx="3054096" cy="91440"/>
+            <a:ext cx="3054096" cy="73152"/>
           </a:xfrm>
           <a:prstGeom prst="rect">
             <a:avLst/>
@@ -1299,8 +1306,8 @@
         </p:nvSpPr>
         <p:spPr>
           <a:xfrm>
-            <a:off x="731520" y="457200"/>
-            <a:ext cx="7315200" cy="365760"/>
+            <a:off x="457200" y="228600"/>
+            <a:ext cx="6400800" cy="274320"/>
           </a:xfrm>
           <a:prstGeom prst="rect">
             <a:avLst/>
@@ -1316,7 +1323,7 @@
               <a:buNone/>
             </a:pPr>
             <a:r>
-              <a:rPr lang="en-US" sz="1100" b="1" dirty="0">
+              <a:rPr lang="en-US" sz="900" b="1" dirty="0">
                 <a:solidFill>
                   <a:srgbClr val="FFCC00"/>
                 </a:solidFill>
@@ -1326,7 +1333,7 @@
               </a:rPr>
               <a:t>HUB LABDIV • IFUSP | ABERTURA &amp; CONCEITO</a:t>
             </a:r>
-            <a:endParaRPr lang="en-US" sz="1100" dirty="0"/>
+            <a:endParaRPr lang="en-US" sz="900" dirty="0"/>
           </a:p>
         </p:txBody>
       </p:sp>
@@ -1338,8 +1345,8 @@
         </p:nvSpPr>
         <p:spPr>
           <a:xfrm>
-            <a:off x="731520" y="822960"/>
-            <a:ext cx="7772400" cy="731520"/>
+            <a:off x="457200" y="502920"/>
+            <a:ext cx="6583680" cy="502920"/>
           </a:xfrm>
           <a:prstGeom prst="rect">
             <a:avLst/>
@@ -1355,7 +1362,7 @@
               <a:buNone/>
             </a:pPr>
             <a:r>
-              <a:rPr lang="en-US" sz="2600" b="1" dirty="0">
+              <a:rPr lang="en-US" sz="2000" b="1" dirty="0">
                 <a:solidFill>
                   <a:srgbClr val="FFFFFF"/>
                 </a:solidFill>
@@ -1365,7 +1372,7 @@
               </a:rPr>
               <a:t>Visão Geral &amp; Conceito do HUB LabDiv</a:t>
             </a:r>
-            <a:endParaRPr lang="en-US" sz="2600" dirty="0"/>
+            <a:endParaRPr lang="en-US" sz="2000" dirty="0"/>
           </a:p>
         </p:txBody>
       </p:sp>
@@ -1377,8 +1384,8 @@
         </p:nvSpPr>
         <p:spPr>
           <a:xfrm>
-            <a:off x="731520" y="1554480"/>
-            <a:ext cx="7772400" cy="457200"/>
+            <a:off x="457200" y="1051560"/>
+            <a:ext cx="6583680" cy="320040"/>
           </a:xfrm>
           <a:prstGeom prst="rect">
             <a:avLst/>
@@ -1394,7 +1401,7 @@
               <a:buNone/>
             </a:pPr>
             <a:r>
-              <a:rPr lang="en-US" sz="1400" b="1" dirty="0">
+              <a:rPr lang="en-US" sz="1100" b="1" dirty="0">
                 <a:solidFill>
                   <a:srgbClr val="FFCC00"/>
                 </a:solidFill>
@@ -1404,7 +1411,7 @@
               </a:rPr>
               <a:t>O Super App de Comunicação Científica para romper os muros da Universidade</a:t>
             </a:r>
-            <a:endParaRPr lang="en-US" sz="1400" dirty="0"/>
+            <a:endParaRPr lang="en-US" sz="1100" dirty="0"/>
           </a:p>
         </p:txBody>
       </p:sp>
@@ -1417,15 +1424,15 @@
           <p:nvPr/>
         </p:nvPicPr>
         <p:blipFill>
-          <a:blip r:embed="rId1"/>
+          <a:blip r:embed="rId2"/>
           <a:stretch>
             <a:fillRect/>
           </a:stretch>
         </p:blipFill>
         <p:spPr>
           <a:xfrm>
-            <a:off x="8961120" y="731520"/>
-            <a:ext cx="2286000" cy="2286000"/>
+            <a:off x="7315200" y="320040"/>
+            <a:ext cx="1371600" cy="1143000"/>
           </a:xfrm>
           <a:prstGeom prst="rect">
             <a:avLst/>
@@ -1440,8 +1447,8 @@
         </p:nvSpPr>
         <p:spPr>
           <a:xfrm>
-            <a:off x="731520" y="2286000"/>
-            <a:ext cx="4937760" cy="1737360"/>
+            <a:off x="457200" y="1508760"/>
+            <a:ext cx="4023360" cy="1325880"/>
           </a:xfrm>
           <a:prstGeom prst="roundRect">
             <a:avLst/>
@@ -1465,24 +1472,24 @@
         </p:nvSpPr>
         <p:spPr>
           <a:xfrm>
-            <a:off x="1005840" y="2468880"/>
-            <a:ext cx="4389120" cy="1371600"/>
-          </a:xfrm>
-          <a:prstGeom prst="rect">
-            <a:avLst/>
-          </a:prstGeom>
-          <a:noFill/>
-          <a:ln/>
-        </p:spPr>
-        <p:txBody>
-          <a:bodyPr wrap="square" rtlCol="0" anchor="ctr"/>
-          <a:lstStyle/>
-          <a:p>
-            <a:pPr indent="0" marL="0">
-              <a:buNone/>
-            </a:pPr>
-            <a:r>
-              <a:rPr lang="en-US" sz="1200" dirty="0">
+            <a:off x="640080" y="1600200"/>
+            <a:ext cx="3657600" cy="1143000"/>
+          </a:xfrm>
+          <a:prstGeom prst="rect">
+            <a:avLst/>
+          </a:prstGeom>
+          <a:noFill/>
+          <a:ln/>
+        </p:spPr>
+        <p:txBody>
+          <a:bodyPr wrap="square" rtlCol="0" anchor="t"/>
+          <a:lstStyle/>
+          <a:p>
+            <a:pPr indent="0" marL="0">
+              <a:buNone/>
+            </a:pPr>
+            <a:r>
+              <a:rPr lang="en-US" sz="950" dirty="0">
                 <a:solidFill>
                   <a:srgbClr val="FFFFFF"/>
                 </a:solidFill>
@@ -1490,9 +1497,9 @@
                 <a:ea typeface="Open Sans" pitchFamily="34" charset="-122"/>
                 <a:cs typeface="Open Sans" pitchFamily="34" charset="-120"/>
               </a:rPr>
-              <a:t>Super App 100% WebApp: Acessível via navegador em qualquer dispositivo, sem necessidade de instalação.</a:t>
-            </a:r>
-            <a:endParaRPr lang="en-US" sz="1200" dirty="0"/>
+              <a:t>Super App: Reúne diversas funções em um único lugar (como 99, WeChat, Mercado Livre, etc.), acessível pela PlayStore (beta fechado) ou direto pelo navegador.</a:t>
+            </a:r>
+            <a:endParaRPr lang="en-US" sz="950" dirty="0"/>
           </a:p>
         </p:txBody>
       </p:sp>
@@ -1504,8 +1511,8 @@
         </p:nvSpPr>
         <p:spPr>
           <a:xfrm>
-            <a:off x="6035040" y="2286000"/>
-            <a:ext cx="4937760" cy="1737360"/>
+            <a:off x="4663440" y="1508760"/>
+            <a:ext cx="4023360" cy="1325880"/>
           </a:xfrm>
           <a:prstGeom prst="roundRect">
             <a:avLst/>
@@ -1529,24 +1536,24 @@
         </p:nvSpPr>
         <p:spPr>
           <a:xfrm>
-            <a:off x="6309360" y="2468880"/>
-            <a:ext cx="4389120" cy="1371600"/>
-          </a:xfrm>
-          <a:prstGeom prst="rect">
-            <a:avLst/>
-          </a:prstGeom>
-          <a:noFill/>
-          <a:ln/>
-        </p:spPr>
-        <p:txBody>
-          <a:bodyPr wrap="square" rtlCol="0" anchor="ctr"/>
-          <a:lstStyle/>
-          <a:p>
-            <a:pPr indent="0" marL="0">
-              <a:buNone/>
-            </a:pPr>
-            <a:r>
-              <a:rPr lang="en-US" sz="1200" dirty="0">
+            <a:off x="4846320" y="1600200"/>
+            <a:ext cx="3657600" cy="1143000"/>
+          </a:xfrm>
+          <a:prstGeom prst="rect">
+            <a:avLst/>
+          </a:prstGeom>
+          <a:noFill/>
+          <a:ln/>
+        </p:spPr>
+        <p:txBody>
+          <a:bodyPr wrap="square" rtlCol="0" anchor="t"/>
+          <a:lstStyle/>
+          <a:p>
+            <a:pPr indent="0" marL="0">
+              <a:buNone/>
+            </a:pPr>
+            <a:r>
+              <a:rPr lang="en-US" sz="950" dirty="0">
                 <a:solidFill>
                   <a:srgbClr val="FFFFFF"/>
                 </a:solidFill>
@@ -1554,9 +1561,9 @@
                 <a:ea typeface="Open Sans" pitchFamily="34" charset="-122"/>
                 <a:cs typeface="Open Sans" pitchFamily="34" charset="-120"/>
               </a:rPr>
-              <a:t>Comunicação Dialógica: Rompe a mera "divulgação passiva" promovendo a co-construção de significado com base em Paulo Freire.</a:t>
-            </a:r>
-            <a:endParaRPr lang="en-US" sz="1200" dirty="0"/>
+              <a:t>Comunicação Dialógica: Rompe a mera "divulgação passiva", promovendo a co-construção de significado com base teórica em "Extensão ou Comunicação?" de Paulo Freire.</a:t>
+            </a:r>
+            <a:endParaRPr lang="en-US" sz="950" dirty="0"/>
           </a:p>
         </p:txBody>
       </p:sp>
@@ -1568,8 +1575,8 @@
         </p:nvSpPr>
         <p:spPr>
           <a:xfrm>
-            <a:off x="731520" y="4297680"/>
-            <a:ext cx="4937760" cy="1737360"/>
+            <a:off x="457200" y="2926080"/>
+            <a:ext cx="4023360" cy="1325880"/>
           </a:xfrm>
           <a:prstGeom prst="roundRect">
             <a:avLst/>
@@ -1593,24 +1600,24 @@
         </p:nvSpPr>
         <p:spPr>
           <a:xfrm>
-            <a:off x="1005840" y="4480560"/>
-            <a:ext cx="4389120" cy="1371600"/>
-          </a:xfrm>
-          <a:prstGeom prst="rect">
-            <a:avLst/>
-          </a:prstGeom>
-          <a:noFill/>
-          <a:ln/>
-        </p:spPr>
-        <p:txBody>
-          <a:bodyPr wrap="square" rtlCol="0" anchor="ctr"/>
-          <a:lstStyle/>
-          <a:p>
-            <a:pPr indent="0" marL="0">
-              <a:buNone/>
-            </a:pPr>
-            <a:r>
-              <a:rPr lang="en-US" sz="1200" dirty="0">
+            <a:off x="640080" y="3017520"/>
+            <a:ext cx="3657600" cy="1143000"/>
+          </a:xfrm>
+          <a:prstGeom prst="rect">
+            <a:avLst/>
+          </a:prstGeom>
+          <a:noFill/>
+          <a:ln/>
+        </p:spPr>
+        <p:txBody>
+          <a:bodyPr wrap="square" rtlCol="0" anchor="t"/>
+          <a:lstStyle/>
+          <a:p>
+            <a:pPr indent="0" marL="0">
+              <a:buNone/>
+            </a:pPr>
+            <a:r>
+              <a:rPr lang="en-US" sz="950" dirty="0">
                 <a:solidFill>
                   <a:srgbClr val="FFFFFF"/>
                 </a:solidFill>
@@ -1618,9 +1625,9 @@
                 <a:ea typeface="Open Sans" pitchFamily="34" charset="-122"/>
                 <a:cs typeface="Open Sans" pitchFamily="34" charset="-120"/>
               </a:rPr>
-              <a:t>Integração Acadêmica: Une acompanhamento de disciplinas, diário discente (Logs), Wiki e Match Acadêmico.</a:t>
-            </a:r>
-            <a:endParaRPr lang="en-US" sz="1200" dirty="0"/>
+              <a:t>Integração Acadêmica: Une o controle do semestre e evolução no curso, uma Wiki com todas as informações do IFUSP e a aba Comunidade para interagir com colegas.</a:t>
+            </a:r>
+            <a:endParaRPr lang="en-US" sz="950" dirty="0"/>
           </a:p>
         </p:txBody>
       </p:sp>
@@ -1632,8 +1639,8 @@
         </p:nvSpPr>
         <p:spPr>
           <a:xfrm>
-            <a:off x="6035040" y="4297680"/>
-            <a:ext cx="4937760" cy="1737360"/>
+            <a:off x="4663440" y="2926080"/>
+            <a:ext cx="4023360" cy="1325880"/>
           </a:xfrm>
           <a:prstGeom prst="roundRect">
             <a:avLst/>
@@ -1657,24 +1664,24 @@
         </p:nvSpPr>
         <p:spPr>
           <a:xfrm>
-            <a:off x="6309360" y="4480560"/>
-            <a:ext cx="4389120" cy="1371600"/>
-          </a:xfrm>
-          <a:prstGeom prst="rect">
-            <a:avLst/>
-          </a:prstGeom>
-          <a:noFill/>
-          <a:ln/>
-        </p:spPr>
-        <p:txBody>
-          <a:bodyPr wrap="square" rtlCol="0" anchor="ctr"/>
-          <a:lstStyle/>
-          <a:p>
-            <a:pPr indent="0" marL="0">
-              <a:buNone/>
-            </a:pPr>
-            <a:r>
-              <a:rPr lang="en-US" sz="1200" dirty="0">
+            <a:off x="4846320" y="3017520"/>
+            <a:ext cx="3657600" cy="1143000"/>
+          </a:xfrm>
+          <a:prstGeom prst="rect">
+            <a:avLst/>
+          </a:prstGeom>
+          <a:noFill/>
+          <a:ln/>
+        </p:spPr>
+        <p:txBody>
+          <a:bodyPr wrap="square" rtlCol="0" anchor="t"/>
+          <a:lstStyle/>
+          <a:p>
+            <a:pPr indent="0" marL="0">
+              <a:buNone/>
+            </a:pPr>
+            <a:r>
+              <a:rPr lang="en-US" sz="950" dirty="0">
                 <a:solidFill>
                   <a:srgbClr val="FFFFFF"/>
                 </a:solidFill>
@@ -1684,7 +1691,46 @@
               </a:rPr>
               <a:t>Código Aberto (AGPLv3): Projeto transparente hospedado no GitHub (JoaoStangorlini/HUB-LabDiv) pronto para ser replicado.</a:t>
             </a:r>
-            <a:endParaRPr lang="en-US" sz="1200" dirty="0"/>
+            <a:endParaRPr lang="en-US" sz="950" dirty="0"/>
+          </a:p>
+        </p:txBody>
+      </p:sp>
+      <p:sp>
+        <p:nvSpPr>
+          <p:cNvPr id="17" name="Text 14"/>
+          <p:cNvSpPr/>
+          <p:nvPr/>
+        </p:nvSpPr>
+        <p:spPr>
+          <a:xfrm>
+            <a:off x="457200" y="4434840"/>
+            <a:ext cx="8229600" cy="320040"/>
+          </a:xfrm>
+          <a:prstGeom prst="rect">
+            <a:avLst/>
+          </a:prstGeom>
+          <a:noFill/>
+          <a:ln/>
+        </p:spPr>
+        <p:txBody>
+          <a:bodyPr wrap="square" rtlCol="0" anchor="ctr"/>
+          <a:lstStyle/>
+          <a:p>
+            <a:pPr algn="ctr" indent="0" marL="0">
+              <a:buNone/>
+            </a:pPr>
+            <a:r>
+              <a:rPr lang="en-US" sz="850" b="1" dirty="0">
+                <a:solidFill>
+                  <a:srgbClr val="FFCC00"/>
+                </a:solidFill>
+                <a:latin typeface="Open Sans" pitchFamily="34" charset="0"/>
+                <a:ea typeface="Open Sans" pitchFamily="34" charset="-122"/>
+                <a:cs typeface="Open Sans" pitchFamily="34" charset="-120"/>
+              </a:rPr>
+              <a:t>WebApp: https://hub-lab-div.vercel.app  |  PlayStore: https://play.google.com/store/apps/details?id=br.usp.ifusp.hublabdiv</a:t>
+            </a:r>
+            <a:endParaRPr lang="en-US" sz="850" dirty="0"/>
           </a:p>
         </p:txBody>
       </p:sp>
@@ -1701,9 +1747,16 @@
   <p:cSld name="Slide 2">
     <p:bg>
       <p:bgPr>
-        <a:solidFill>
-          <a:srgbClr val="09090B"/>
-        </a:solidFill>
+        <a:blipFill dpi="0" rotWithShape="1">
+          <a:blip r:embed="rId1">
+            <a:lum/>
+          </a:blip>
+          <a:srcRect/>
+          <a:stretch>
+            <a:fillRect/>
+          </a:stretch>
+        </a:blipFill>
+        <a:effectLst/>
       </p:bgPr>
     </p:bg>
     <p:spTree>
@@ -1729,7 +1782,7 @@
         <p:spPr>
           <a:xfrm>
             <a:off x="0" y="0"/>
-            <a:ext cx="3044952" cy="91440"/>
+            <a:ext cx="3044952" cy="73152"/>
           </a:xfrm>
           <a:prstGeom prst="rect">
             <a:avLst/>
@@ -1749,7 +1802,7 @@
         <p:spPr>
           <a:xfrm>
             <a:off x="3044952" y="0"/>
-            <a:ext cx="3044952" cy="91440"/>
+            <a:ext cx="3044952" cy="73152"/>
           </a:xfrm>
           <a:prstGeom prst="rect">
             <a:avLst/>
@@ -1769,7 +1822,7 @@
         <p:spPr>
           <a:xfrm>
             <a:off x="6089904" y="0"/>
-            <a:ext cx="3054096" cy="91440"/>
+            <a:ext cx="3054096" cy="73152"/>
           </a:xfrm>
           <a:prstGeom prst="rect">
             <a:avLst/>
@@ -1788,8 +1841,8 @@
         </p:nvSpPr>
         <p:spPr>
           <a:xfrm>
-            <a:off x="731520" y="457200"/>
-            <a:ext cx="7315200" cy="365760"/>
+            <a:off x="457200" y="228600"/>
+            <a:ext cx="8229600" cy="274320"/>
           </a:xfrm>
           <a:prstGeom prst="rect">
             <a:avLst/>
@@ -1805,7 +1858,7 @@
               <a:buNone/>
             </a:pPr>
             <a:r>
-              <a:rPr lang="en-US" sz="1100" b="1" dirty="0">
+              <a:rPr lang="en-US" sz="900" b="1" dirty="0">
                 <a:solidFill>
                   <a:srgbClr val="FFCC00"/>
                 </a:solidFill>
@@ -1815,7 +1868,7 @@
               </a:rPr>
               <a:t>ESTRUTURA DOS 3 EIXOS | HUB LABDIV</a:t>
             </a:r>
-            <a:endParaRPr lang="en-US" sz="1100" dirty="0"/>
+            <a:endParaRPr lang="en-US" sz="900" dirty="0"/>
           </a:p>
         </p:txBody>
       </p:sp>
@@ -1827,8 +1880,8 @@
         </p:nvSpPr>
         <p:spPr>
           <a:xfrm>
-            <a:off x="731520" y="822960"/>
-            <a:ext cx="10515600" cy="731520"/>
+            <a:off x="457200" y="502920"/>
+            <a:ext cx="8229600" cy="502920"/>
           </a:xfrm>
           <a:prstGeom prst="rect">
             <a:avLst/>
@@ -1844,7 +1897,7 @@
               <a:buNone/>
             </a:pPr>
             <a:r>
-              <a:rPr lang="en-US" sz="2600" b="1" dirty="0">
+              <a:rPr lang="en-US" sz="2000" b="1" dirty="0">
                 <a:solidFill>
                   <a:srgbClr val="FFFFFF"/>
                 </a:solidFill>
@@ -1854,20 +1907,59 @@
               </a:rPr>
               <a:t>Divisão do HUB em 3 Eixos Principais</a:t>
             </a:r>
-            <a:endParaRPr lang="en-US" sz="2600" dirty="0"/>
-          </a:p>
-        </p:txBody>
-      </p:sp>
-      <p:sp>
-        <p:nvSpPr>
-          <p:cNvPr id="7" name="Shape 5"/>
-          <p:cNvSpPr/>
-          <p:nvPr/>
-        </p:nvSpPr>
-        <p:spPr>
-          <a:xfrm>
-            <a:off x="731520" y="1828800"/>
-            <a:ext cx="3291840" cy="4389120"/>
+            <a:endParaRPr lang="en-US" sz="2000" dirty="0"/>
+          </a:p>
+        </p:txBody>
+      </p:sp>
+      <p:sp>
+        <p:nvSpPr>
+          <p:cNvPr id="7" name="Text 5"/>
+          <p:cNvSpPr/>
+          <p:nvPr/>
+        </p:nvSpPr>
+        <p:spPr>
+          <a:xfrm>
+            <a:off x="457200" y="1051560"/>
+            <a:ext cx="8229600" cy="320040"/>
+          </a:xfrm>
+          <a:prstGeom prst="rect">
+            <a:avLst/>
+          </a:prstGeom>
+          <a:noFill/>
+          <a:ln/>
+        </p:spPr>
+        <p:txBody>
+          <a:bodyPr wrap="square" rtlCol="0" anchor="ctr"/>
+          <a:lstStyle/>
+          <a:p>
+            <a:pPr indent="0" marL="0">
+              <a:buNone/>
+            </a:pPr>
+            <a:r>
+              <a:rPr lang="en-US" sz="1100" b="1" dirty="0">
+                <a:solidFill>
+                  <a:srgbClr val="FFCC00"/>
+                </a:solidFill>
+                <a:latin typeface="Open Sans" pitchFamily="34" charset="0"/>
+                <a:ea typeface="Open Sans" pitchFamily="34" charset="-122"/>
+                <a:cs typeface="Open Sans" pitchFamily="34" charset="-120"/>
+              </a:rPr>
+              <a:t>As 3 Frentes Fundamentais da Plataforma HUB LabDiv</a:t>
+            </a:r>
+            <a:endParaRPr lang="en-US" sz="1100" dirty="0"/>
+          </a:p>
+        </p:txBody>
+      </p:sp>
+      <p:sp>
+        <p:nvSpPr>
+          <p:cNvPr id="8" name="Shape 6"/>
+          <p:cNvSpPr/>
+          <p:nvPr/>
+        </p:nvSpPr>
+        <p:spPr>
+          <a:xfrm>
+            <a:off x="457200" y="1508760"/>
+            <a:ext cx="2560320" cy="3154680"/>
           </a:xfrm>
           <a:prstGeom prst="roundRect">
             <a:avLst/>
@@ -1875,7 +1967,7 @@
           <a:solidFill>
             <a:srgbClr val="1E1E1E"/>
           </a:solidFill>
-          <a:ln w="25400">
+          <a:ln w="19050">
             <a:solidFill>
               <a:srgbClr val="FFCC00"/>
             </a:solidFill>
@@ -1885,14 +1977,14 @@
       </p:sp>
       <p:sp>
         <p:nvSpPr>
-          <p:cNvPr id="8" name="Text 6"/>
-          <p:cNvSpPr/>
-          <p:nvPr/>
-        </p:nvSpPr>
-        <p:spPr>
-          <a:xfrm>
-            <a:off x="1005840" y="2103120"/>
-            <a:ext cx="2743200" cy="548640"/>
+          <p:cNvPr id="9" name="Text 7"/>
+          <p:cNvSpPr/>
+          <p:nvPr/>
+        </p:nvSpPr>
+        <p:spPr>
+          <a:xfrm>
+            <a:off x="640080" y="1645920"/>
+            <a:ext cx="2194560" cy="365760"/>
           </a:xfrm>
           <a:prstGeom prst="rect">
             <a:avLst/>
@@ -1908,7 +2000,7 @@
               <a:buNone/>
             </a:pPr>
             <a:r>
-              <a:rPr lang="en-US" sz="1600" b="1" dirty="0">
+              <a:rPr lang="en-US" sz="1200" b="1" dirty="0">
                 <a:solidFill>
                   <a:srgbClr val="FFFFFF"/>
                 </a:solidFill>
@@ -1918,20 +2010,20 @@
               </a:rPr>
               <a:t>1. Eixo Comunidade</a:t>
             </a:r>
-            <a:endParaRPr lang="en-US" sz="1600" dirty="0"/>
-          </a:p>
-        </p:txBody>
-      </p:sp>
-      <p:sp>
-        <p:nvSpPr>
-          <p:cNvPr id="9" name="Text 7"/>
-          <p:cNvSpPr/>
-          <p:nvPr/>
-        </p:nvSpPr>
-        <p:spPr>
-          <a:xfrm>
-            <a:off x="1005840" y="2743200"/>
-            <a:ext cx="2743200" cy="365760"/>
+            <a:endParaRPr lang="en-US" sz="1200" dirty="0"/>
+          </a:p>
+        </p:txBody>
+      </p:sp>
+      <p:sp>
+        <p:nvSpPr>
+          <p:cNvPr id="10" name="Text 8"/>
+          <p:cNvSpPr/>
+          <p:nvPr/>
+        </p:nvSpPr>
+        <p:spPr>
+          <a:xfrm>
+            <a:off x="640080" y="2057400"/>
+            <a:ext cx="2194560" cy="274320"/>
           </a:xfrm>
           <a:prstGeom prst="rect">
             <a:avLst/>
@@ -1947,7 +2039,7 @@
               <a:buNone/>
             </a:pPr>
             <a:r>
-              <a:rPr lang="en-US" sz="1000" b="1" dirty="0">
+              <a:rPr lang="en-US" sz="850" b="1" dirty="0">
                 <a:solidFill>
                   <a:srgbClr val="FFCC00"/>
                 </a:solidFill>
@@ -1957,36 +2049,36 @@
               </a:rPr>
               <a:t>REDE SOCIAL &amp; LOGS</a:t>
             </a:r>
-            <a:endParaRPr lang="en-US" sz="1000" dirty="0"/>
-          </a:p>
-        </p:txBody>
-      </p:sp>
-      <p:sp>
-        <p:nvSpPr>
-          <p:cNvPr id="10" name="Text 8"/>
-          <p:cNvSpPr/>
-          <p:nvPr/>
-        </p:nvSpPr>
-        <p:spPr>
-          <a:xfrm>
-            <a:off x="1005840" y="3291840"/>
-            <a:ext cx="2743200" cy="2560320"/>
-          </a:xfrm>
-          <a:prstGeom prst="rect">
-            <a:avLst/>
-          </a:prstGeom>
-          <a:noFill/>
-          <a:ln/>
-        </p:spPr>
-        <p:txBody>
-          <a:bodyPr wrap="square" rtlCol="0" anchor="ctr"/>
-          <a:lstStyle/>
-          <a:p>
-            <a:pPr indent="0" marL="0">
-              <a:buNone/>
-            </a:pPr>
-            <a:r>
-              <a:rPr lang="en-US" sz="1200" dirty="0">
+            <a:endParaRPr lang="en-US" sz="850" dirty="0"/>
+          </a:p>
+        </p:txBody>
+      </p:sp>
+      <p:sp>
+        <p:nvSpPr>
+          <p:cNvPr id="11" name="Text 9"/>
+          <p:cNvSpPr/>
+          <p:nvPr/>
+        </p:nvSpPr>
+        <p:spPr>
+          <a:xfrm>
+            <a:off x="640080" y="2423160"/>
+            <a:ext cx="2194560" cy="2103120"/>
+          </a:xfrm>
+          <a:prstGeom prst="rect">
+            <a:avLst/>
+          </a:prstGeom>
+          <a:noFill/>
+          <a:ln/>
+        </p:spPr>
+        <p:txBody>
+          <a:bodyPr wrap="square" rtlCol="0" anchor="t"/>
+          <a:lstStyle/>
+          <a:p>
+            <a:pPr indent="0" marL="0">
+              <a:buNone/>
+            </a:pPr>
+            <a:r>
+              <a:rPr lang="en-US" sz="1000" dirty="0">
                 <a:solidFill>
                   <a:srgbClr val="FFFFFF"/>
                 </a:solidFill>
@@ -1996,20 +2088,20 @@
               </a:rPr>
               <a:t>Feed de comunicação científica dialógica, quizzes, narração, galeria de Arte e Logs de vivência discente.</a:t>
             </a:r>
-            <a:endParaRPr lang="en-US" sz="1200" dirty="0"/>
-          </a:p>
-        </p:txBody>
-      </p:sp>
-      <p:sp>
-        <p:nvSpPr>
-          <p:cNvPr id="11" name="Shape 9"/>
-          <p:cNvSpPr/>
-          <p:nvPr/>
-        </p:nvSpPr>
-        <p:spPr>
-          <a:xfrm>
-            <a:off x="4297680" y="1828800"/>
-            <a:ext cx="3291840" cy="4389120"/>
+            <a:endParaRPr lang="en-US" sz="1000" dirty="0"/>
+          </a:p>
+        </p:txBody>
+      </p:sp>
+      <p:sp>
+        <p:nvSpPr>
+          <p:cNvPr id="12" name="Shape 10"/>
+          <p:cNvSpPr/>
+          <p:nvPr/>
+        </p:nvSpPr>
+        <p:spPr>
+          <a:xfrm>
+            <a:off x="3291840" y="1508760"/>
+            <a:ext cx="2560320" cy="3154680"/>
           </a:xfrm>
           <a:prstGeom prst="roundRect">
             <a:avLst/>
@@ -2017,7 +2109,7 @@
           <a:solidFill>
             <a:srgbClr val="1E1E1E"/>
           </a:solidFill>
-          <a:ln w="25400">
+          <a:ln w="19050">
             <a:solidFill>
               <a:srgbClr val="38BDF8"/>
             </a:solidFill>
@@ -2027,14 +2119,14 @@
       </p:sp>
       <p:sp>
         <p:nvSpPr>
-          <p:cNvPr id="12" name="Text 10"/>
-          <p:cNvSpPr/>
-          <p:nvPr/>
-        </p:nvSpPr>
-        <p:spPr>
-          <a:xfrm>
-            <a:off x="4572000" y="2103120"/>
-            <a:ext cx="2743200" cy="548640"/>
+          <p:cNvPr id="13" name="Text 11"/>
+          <p:cNvSpPr/>
+          <p:nvPr/>
+        </p:nvSpPr>
+        <p:spPr>
+          <a:xfrm>
+            <a:off x="3474720" y="1645920"/>
+            <a:ext cx="2194560" cy="365760"/>
           </a:xfrm>
           <a:prstGeom prst="rect">
             <a:avLst/>
@@ -2050,7 +2142,7 @@
               <a:buNone/>
             </a:pPr>
             <a:r>
-              <a:rPr lang="en-US" sz="1600" b="1" dirty="0">
+              <a:rPr lang="en-US" sz="1200" b="1" dirty="0">
                 <a:solidFill>
                   <a:srgbClr val="FFFFFF"/>
                 </a:solidFill>
@@ -2060,20 +2152,20 @@
               </a:rPr>
               <a:t>2. Eixo CGIF</a:t>
             </a:r>
-            <a:endParaRPr lang="en-US" sz="1600" dirty="0"/>
-          </a:p>
-        </p:txBody>
-      </p:sp>
-      <p:sp>
-        <p:nvSpPr>
-          <p:cNvPr id="13" name="Text 11"/>
-          <p:cNvSpPr/>
-          <p:nvPr/>
-        </p:nvSpPr>
-        <p:spPr>
-          <a:xfrm>
-            <a:off x="4572000" y="2743200"/>
-            <a:ext cx="2743200" cy="365760"/>
+            <a:endParaRPr lang="en-US" sz="1200" dirty="0"/>
+          </a:p>
+        </p:txBody>
+      </p:sp>
+      <p:sp>
+        <p:nvSpPr>
+          <p:cNvPr id="14" name="Text 12"/>
+          <p:cNvSpPr/>
+          <p:nvPr/>
+        </p:nvSpPr>
+        <p:spPr>
+          <a:xfrm>
+            <a:off x="3474720" y="2057400"/>
+            <a:ext cx="2194560" cy="274320"/>
           </a:xfrm>
           <a:prstGeom prst="rect">
             <a:avLst/>
@@ -2089,7 +2181,7 @@
               <a:buNone/>
             </a:pPr>
             <a:r>
-              <a:rPr lang="en-US" sz="1000" b="1" dirty="0">
+              <a:rPr lang="en-US" sz="850" b="1" dirty="0">
                 <a:solidFill>
                   <a:srgbClr val="38BDF8"/>
                 </a:solidFill>
@@ -2099,36 +2191,36 @@
               </a:rPr>
               <a:t>INFORMAÇÃO &amp; WIKI</a:t>
             </a:r>
-            <a:endParaRPr lang="en-US" sz="1000" dirty="0"/>
-          </a:p>
-        </p:txBody>
-      </p:sp>
-      <p:sp>
-        <p:nvSpPr>
-          <p:cNvPr id="14" name="Text 12"/>
-          <p:cNvSpPr/>
-          <p:nvPr/>
-        </p:nvSpPr>
-        <p:spPr>
-          <a:xfrm>
-            <a:off x="4572000" y="3291840"/>
-            <a:ext cx="2743200" cy="2560320"/>
-          </a:xfrm>
-          <a:prstGeom prst="rect">
-            <a:avLst/>
-          </a:prstGeom>
-          <a:noFill/>
-          <a:ln/>
-        </p:spPr>
-        <p:txBody>
-          <a:bodyPr wrap="square" rtlCol="0" anchor="ctr"/>
-          <a:lstStyle/>
-          <a:p>
-            <a:pPr indent="0" marL="0">
-              <a:buNone/>
-            </a:pPr>
-            <a:r>
-              <a:rPr lang="en-US" sz="1200" dirty="0">
+            <a:endParaRPr lang="en-US" sz="850" dirty="0"/>
+          </a:p>
+        </p:txBody>
+      </p:sp>
+      <p:sp>
+        <p:nvSpPr>
+          <p:cNvPr id="15" name="Text 13"/>
+          <p:cNvSpPr/>
+          <p:nvPr/>
+        </p:nvSpPr>
+        <p:spPr>
+          <a:xfrm>
+            <a:off x="3474720" y="2423160"/>
+            <a:ext cx="2194560" cy="2103120"/>
+          </a:xfrm>
+          <a:prstGeom prst="rect">
+            <a:avLst/>
+          </a:prstGeom>
+          <a:noFill/>
+          <a:ln/>
+        </p:spPr>
+        <p:txBody>
+          <a:bodyPr wrap="square" rtlCol="0" anchor="t"/>
+          <a:lstStyle/>
+          <a:p>
+            <a:pPr indent="0" marL="0">
+              <a:buNone/>
+            </a:pPr>
+            <a:r>
+              <a:rPr lang="en-US" sz="1000" dirty="0">
                 <a:solidFill>
                   <a:srgbClr val="FFFFFF"/>
                 </a:solidFill>
@@ -2136,22 +2228,22 @@
                 <a:ea typeface="Open Sans" pitchFamily="34" charset="-122"/>
                 <a:cs typeface="Open Sans" pitchFamily="34" charset="-120"/>
               </a:rPr>
-              <a:t>Wiki institucional centralizada do IFUSP, manuais do curso, oportunidades (PUB/IC), iniciativas e mapa interativo.</a:t>
-            </a:r>
-            <a:endParaRPr lang="en-US" sz="1200" dirty="0"/>
-          </a:p>
-        </p:txBody>
-      </p:sp>
-      <p:sp>
-        <p:nvSpPr>
-          <p:cNvPr id="15" name="Shape 13"/>
-          <p:cNvSpPr/>
-          <p:nvPr/>
-        </p:nvSpPr>
-        <p:spPr>
-          <a:xfrm>
-            <a:off x="7863840" y="1828800"/>
-            <a:ext cx="3291840" cy="4389120"/>
+              <a:t>Wiki institucional centralizada do IFUSP, manuais do curso, oportunidades (PUB/IC), iniciativas e mapa interativo com QR Code.</a:t>
+            </a:r>
+            <a:endParaRPr lang="en-US" sz="1000" dirty="0"/>
+          </a:p>
+        </p:txBody>
+      </p:sp>
+      <p:sp>
+        <p:nvSpPr>
+          <p:cNvPr id="16" name="Shape 14"/>
+          <p:cNvSpPr/>
+          <p:nvPr/>
+        </p:nvSpPr>
+        <p:spPr>
+          <a:xfrm>
+            <a:off x="6126480" y="1508760"/>
+            <a:ext cx="2560320" cy="3154680"/>
           </a:xfrm>
           <a:prstGeom prst="roundRect">
             <a:avLst/>
@@ -2159,7 +2251,7 @@
           <a:solidFill>
             <a:srgbClr val="1E1E1E"/>
           </a:solidFill>
-          <a:ln w="25400">
+          <a:ln w="19050">
             <a:solidFill>
               <a:srgbClr val="F14343"/>
             </a:solidFill>
@@ -2169,14 +2261,14 @@
       </p:sp>
       <p:sp>
         <p:nvSpPr>
-          <p:cNvPr id="16" name="Text 14"/>
-          <p:cNvSpPr/>
-          <p:nvPr/>
-        </p:nvSpPr>
-        <p:spPr>
-          <a:xfrm>
-            <a:off x="8138160" y="2103120"/>
-            <a:ext cx="2743200" cy="548640"/>
+          <p:cNvPr id="17" name="Text 15"/>
+          <p:cNvSpPr/>
+          <p:nvPr/>
+        </p:nvSpPr>
+        <p:spPr>
+          <a:xfrm>
+            <a:off x="6309360" y="1645920"/>
+            <a:ext cx="2194560" cy="365760"/>
           </a:xfrm>
           <a:prstGeom prst="rect">
             <a:avLst/>
@@ -2192,7 +2284,7 @@
               <a:buNone/>
             </a:pPr>
             <a:r>
-              <a:rPr lang="en-US" sz="1600" b="1" dirty="0">
+              <a:rPr lang="en-US" sz="1200" b="1" dirty="0">
                 <a:solidFill>
                   <a:srgbClr val="FFFFFF"/>
                 </a:solidFill>
@@ -2202,20 +2294,20 @@
               </a:rPr>
               <a:t>3. Eixo Ferramentas</a:t>
             </a:r>
-            <a:endParaRPr lang="en-US" sz="1600" dirty="0"/>
-          </a:p>
-        </p:txBody>
-      </p:sp>
-      <p:sp>
-        <p:nvSpPr>
-          <p:cNvPr id="17" name="Text 15"/>
-          <p:cNvSpPr/>
-          <p:nvPr/>
-        </p:nvSpPr>
-        <p:spPr>
-          <a:xfrm>
-            <a:off x="8138160" y="2743200"/>
-            <a:ext cx="2743200" cy="365760"/>
+            <a:endParaRPr lang="en-US" sz="1200" dirty="0"/>
+          </a:p>
+        </p:txBody>
+      </p:sp>
+      <p:sp>
+        <p:nvSpPr>
+          <p:cNvPr id="18" name="Text 16"/>
+          <p:cNvSpPr/>
+          <p:nvPr/>
+        </p:nvSpPr>
+        <p:spPr>
+          <a:xfrm>
+            <a:off x="6309360" y="2057400"/>
+            <a:ext cx="2194560" cy="274320"/>
           </a:xfrm>
           <a:prstGeom prst="rect">
             <a:avLst/>
@@ -2231,7 +2323,7 @@
               <a:buNone/>
             </a:pPr>
             <a:r>
-              <a:rPr lang="en-US" sz="1000" b="1" dirty="0">
+              <a:rPr lang="en-US" sz="850" b="1" dirty="0">
                 <a:solidFill>
                   <a:srgbClr val="F14343"/>
                 </a:solidFill>
@@ -2241,36 +2333,36 @@
               </a:rPr>
               <a:t>ESTUDO &amp; PESQUISA</a:t>
             </a:r>
-            <a:endParaRPr lang="en-US" sz="1000" dirty="0"/>
-          </a:p>
-        </p:txBody>
-      </p:sp>
-      <p:sp>
-        <p:nvSpPr>
-          <p:cNvPr id="18" name="Text 16"/>
-          <p:cNvSpPr/>
-          <p:nvPr/>
-        </p:nvSpPr>
-        <p:spPr>
-          <a:xfrm>
-            <a:off x="8138160" y="3291840"/>
-            <a:ext cx="2743200" cy="2560320"/>
-          </a:xfrm>
-          <a:prstGeom prst="rect">
-            <a:avLst/>
-          </a:prstGeom>
-          <a:noFill/>
-          <a:ln/>
-        </p:spPr>
-        <p:txBody>
-          <a:bodyPr wrap="square" rtlCol="0" anchor="ctr"/>
-          <a:lstStyle/>
-          <a:p>
-            <a:pPr indent="0" marL="0">
-              <a:buNone/>
-            </a:pPr>
-            <a:r>
-              <a:rPr lang="en-US" sz="1200" dirty="0">
+            <a:endParaRPr lang="en-US" sz="850" dirty="0"/>
+          </a:p>
+        </p:txBody>
+      </p:sp>
+      <p:sp>
+        <p:nvSpPr>
+          <p:cNvPr id="19" name="Text 17"/>
+          <p:cNvSpPr/>
+          <p:nvPr/>
+        </p:nvSpPr>
+        <p:spPr>
+          <a:xfrm>
+            <a:off x="6309360" y="2423160"/>
+            <a:ext cx="2194560" cy="2103120"/>
+          </a:xfrm>
+          <a:prstGeom prst="rect">
+            <a:avLst/>
+          </a:prstGeom>
+          <a:noFill/>
+          <a:ln/>
+        </p:spPr>
+        <p:txBody>
+          <a:bodyPr wrap="square" rtlCol="0" anchor="t"/>
+          <a:lstStyle/>
+          <a:p>
+            <a:pPr indent="0" marL="0">
+              <a:buNone/>
+            </a:pPr>
+            <a:r>
+              <a:rPr lang="en-US" sz="1000" dirty="0">
                 <a:solidFill>
                   <a:srgbClr val="FFFFFF"/>
                 </a:solidFill>
@@ -2280,7 +2372,7 @@
               </a:rPr>
               <a:t>Planejador de grade horária 1h:1h, acompanhamento de trilhas do curso e Match Acadêmico ("Quero uma IC").</a:t>
             </a:r>
-            <a:endParaRPr lang="en-US" sz="1200" dirty="0"/>
+            <a:endParaRPr lang="en-US" sz="1000" dirty="0"/>
           </a:p>
         </p:txBody>
       </p:sp>
@@ -2297,9 +2389,16 @@
   <p:cSld name="Slide 3">
     <p:bg>
       <p:bgPr>
-        <a:solidFill>
-          <a:srgbClr val="09090B"/>
-        </a:solidFill>
+        <a:blipFill dpi="0" rotWithShape="1">
+          <a:blip r:embed="rId1">
+            <a:lum/>
+          </a:blip>
+          <a:srcRect/>
+          <a:stretch>
+            <a:fillRect/>
+          </a:stretch>
+        </a:blipFill>
+        <a:effectLst/>
       </p:bgPr>
     </p:bg>
     <p:spTree>
@@ -2325,7 +2424,7 @@
         <p:spPr>
           <a:xfrm>
             <a:off x="0" y="0"/>
-            <a:ext cx="3044952" cy="91440"/>
+            <a:ext cx="3044952" cy="73152"/>
           </a:xfrm>
           <a:prstGeom prst="rect">
             <a:avLst/>
@@ -2345,7 +2444,7 @@
         <p:spPr>
           <a:xfrm>
             <a:off x="3044952" y="0"/>
-            <a:ext cx="3044952" cy="91440"/>
+            <a:ext cx="3044952" cy="73152"/>
           </a:xfrm>
           <a:prstGeom prst="rect">
             <a:avLst/>
@@ -2365,7 +2464,7 @@
         <p:spPr>
           <a:xfrm>
             <a:off x="6089904" y="0"/>
-            <a:ext cx="3054096" cy="91440"/>
+            <a:ext cx="3054096" cy="73152"/>
           </a:xfrm>
           <a:prstGeom prst="rect">
             <a:avLst/>
@@ -2384,8 +2483,8 @@
         </p:nvSpPr>
         <p:spPr>
           <a:xfrm>
-            <a:off x="731520" y="457200"/>
-            <a:ext cx="7315200" cy="365760"/>
+            <a:off x="457200" y="228600"/>
+            <a:ext cx="8229600" cy="274320"/>
           </a:xfrm>
           <a:prstGeom prst="rect">
             <a:avLst/>
@@ -2401,7 +2500,7 @@
               <a:buNone/>
             </a:pPr>
             <a:r>
-              <a:rPr lang="en-US" sz="1100" b="1" dirty="0">
+              <a:rPr lang="en-US" sz="900" b="1" dirty="0">
                 <a:solidFill>
                   <a:srgbClr val="FFCC00"/>
                 </a:solidFill>
@@ -2411,7 +2510,7 @@
               </a:rPr>
               <a:t>EIXO 1 — COMUNIDADE | HUB LABDIV</a:t>
             </a:r>
-            <a:endParaRPr lang="en-US" sz="1100" dirty="0"/>
+            <a:endParaRPr lang="en-US" sz="900" dirty="0"/>
           </a:p>
         </p:txBody>
       </p:sp>
@@ -2423,8 +2522,8 @@
         </p:nvSpPr>
         <p:spPr>
           <a:xfrm>
-            <a:off x="731520" y="822960"/>
-            <a:ext cx="10515600" cy="731520"/>
+            <a:off x="457200" y="502920"/>
+            <a:ext cx="8229600" cy="502920"/>
           </a:xfrm>
           <a:prstGeom prst="rect">
             <a:avLst/>
@@ -2440,7 +2539,7 @@
               <a:buNone/>
             </a:pPr>
             <a:r>
-              <a:rPr lang="en-US" sz="2600" b="1" dirty="0">
+              <a:rPr lang="en-US" sz="2000" b="1" dirty="0">
                 <a:solidFill>
                   <a:srgbClr val="FFFFFF"/>
                 </a:solidFill>
@@ -2450,20 +2549,59 @@
               </a:rPr>
               <a:t>Aba Comunidade: Fluxo, Logs &amp; Arte</a:t>
             </a:r>
-            <a:endParaRPr lang="en-US" sz="2600" dirty="0"/>
-          </a:p>
-        </p:txBody>
-      </p:sp>
-      <p:sp>
-        <p:nvSpPr>
-          <p:cNvPr id="7" name="Shape 5"/>
-          <p:cNvSpPr/>
-          <p:nvPr/>
-        </p:nvSpPr>
-        <p:spPr>
-          <a:xfrm>
-            <a:off x="731520" y="1828800"/>
-            <a:ext cx="3291840" cy="4389120"/>
+            <a:endParaRPr lang="en-US" sz="2000" dirty="0"/>
+          </a:p>
+        </p:txBody>
+      </p:sp>
+      <p:sp>
+        <p:nvSpPr>
+          <p:cNvPr id="7" name="Text 5"/>
+          <p:cNvSpPr/>
+          <p:nvPr/>
+        </p:nvSpPr>
+        <p:spPr>
+          <a:xfrm>
+            <a:off x="457200" y="1051560"/>
+            <a:ext cx="8229600" cy="320040"/>
+          </a:xfrm>
+          <a:prstGeom prst="rect">
+            <a:avLst/>
+          </a:prstGeom>
+          <a:noFill/>
+          <a:ln/>
+        </p:spPr>
+        <p:txBody>
+          <a:bodyPr wrap="square" rtlCol="0" anchor="ctr"/>
+          <a:lstStyle/>
+          <a:p>
+            <a:pPr indent="0" marL="0">
+              <a:buNone/>
+            </a:pPr>
+            <a:r>
+              <a:rPr lang="en-US" sz="1100" b="1" dirty="0">
+                <a:solidFill>
+                  <a:srgbClr val="FFCC00"/>
+                </a:solidFill>
+                <a:latin typeface="Open Sans" pitchFamily="34" charset="0"/>
+                <a:ea typeface="Open Sans" pitchFamily="34" charset="-122"/>
+                <a:cs typeface="Open Sans" pitchFamily="34" charset="-120"/>
+              </a:rPr>
+              <a:t>Descrição detalhada das 3 seções integradas do Eixo Comunidade</a:t>
+            </a:r>
+            <a:endParaRPr lang="en-US" sz="1100" dirty="0"/>
+          </a:p>
+        </p:txBody>
+      </p:sp>
+      <p:sp>
+        <p:nvSpPr>
+          <p:cNvPr id="8" name="Shape 6"/>
+          <p:cNvSpPr/>
+          <p:nvPr/>
+        </p:nvSpPr>
+        <p:spPr>
+          <a:xfrm>
+            <a:off x="457200" y="1508760"/>
+            <a:ext cx="2560320" cy="3154680"/>
           </a:xfrm>
           <a:prstGeom prst="roundRect">
             <a:avLst/>
@@ -2471,7 +2609,7 @@
           <a:solidFill>
             <a:srgbClr val="1E1E1E"/>
           </a:solidFill>
-          <a:ln w="25400">
+          <a:ln w="19050">
             <a:solidFill>
               <a:srgbClr val="FFCC00"/>
             </a:solidFill>
@@ -2481,14 +2619,14 @@
       </p:sp>
       <p:sp>
         <p:nvSpPr>
-          <p:cNvPr id="8" name="Text 6"/>
-          <p:cNvSpPr/>
-          <p:nvPr/>
-        </p:nvSpPr>
-        <p:spPr>
-          <a:xfrm>
-            <a:off x="1005840" y="2103120"/>
-            <a:ext cx="2743200" cy="548640"/>
+          <p:cNvPr id="9" name="Text 7"/>
+          <p:cNvSpPr/>
+          <p:nvPr/>
+        </p:nvSpPr>
+        <p:spPr>
+          <a:xfrm>
+            <a:off x="640080" y="1645920"/>
+            <a:ext cx="2194560" cy="365760"/>
           </a:xfrm>
           <a:prstGeom prst="rect">
             <a:avLst/>
@@ -2504,7 +2642,7 @@
               <a:buNone/>
             </a:pPr>
             <a:r>
-              <a:rPr lang="en-US" sz="1600" b="1" dirty="0">
+              <a:rPr lang="en-US" sz="1200" b="1" dirty="0">
                 <a:solidFill>
                   <a:srgbClr val="FFFFFF"/>
                 </a:solidFill>
@@ -2514,20 +2652,20 @@
               </a:rPr>
               <a:t>1. Fluxo</a:t>
             </a:r>
-            <a:endParaRPr lang="en-US" sz="1600" dirty="0"/>
-          </a:p>
-        </p:txBody>
-      </p:sp>
-      <p:sp>
-        <p:nvSpPr>
-          <p:cNvPr id="9" name="Text 7"/>
-          <p:cNvSpPr/>
-          <p:nvPr/>
-        </p:nvSpPr>
-        <p:spPr>
-          <a:xfrm>
-            <a:off x="1005840" y="2743200"/>
-            <a:ext cx="2743200" cy="365760"/>
+            <a:endParaRPr lang="en-US" sz="1200" dirty="0"/>
+          </a:p>
+        </p:txBody>
+      </p:sp>
+      <p:sp>
+        <p:nvSpPr>
+          <p:cNvPr id="10" name="Text 8"/>
+          <p:cNvSpPr/>
+          <p:nvPr/>
+        </p:nvSpPr>
+        <p:spPr>
+          <a:xfrm>
+            <a:off x="640080" y="2057400"/>
+            <a:ext cx="2194560" cy="274320"/>
           </a:xfrm>
           <a:prstGeom prst="rect">
             <a:avLst/>
@@ -2543,7 +2681,7 @@
               <a:buNone/>
             </a:pPr>
             <a:r>
-              <a:rPr lang="en-US" sz="1000" b="1" dirty="0">
+              <a:rPr lang="en-US" sz="850" b="1" dirty="0">
                 <a:solidFill>
                   <a:srgbClr val="FFCC00"/>
                 </a:solidFill>
@@ -2553,36 +2691,36 @@
               </a:rPr>
               <a:t>COMUNICAÇÃO DIALÓGICA</a:t>
             </a:r>
-            <a:endParaRPr lang="en-US" sz="1000" dirty="0"/>
-          </a:p>
-        </p:txBody>
-      </p:sp>
-      <p:sp>
-        <p:nvSpPr>
-          <p:cNvPr id="10" name="Text 8"/>
-          <p:cNvSpPr/>
-          <p:nvPr/>
-        </p:nvSpPr>
-        <p:spPr>
-          <a:xfrm>
-            <a:off x="1005840" y="3291840"/>
-            <a:ext cx="2743200" cy="2560320"/>
-          </a:xfrm>
-          <a:prstGeom prst="rect">
-            <a:avLst/>
-          </a:prstGeom>
-          <a:noFill/>
-          <a:ln/>
-        </p:spPr>
-        <p:txBody>
-          <a:bodyPr wrap="square" rtlCol="0" anchor="ctr"/>
-          <a:lstStyle/>
-          <a:p>
-            <a:pPr indent="0" marL="0">
-              <a:buNone/>
-            </a:pPr>
-            <a:r>
-              <a:rPr lang="en-US" sz="1200" dirty="0">
+            <a:endParaRPr lang="en-US" sz="850" dirty="0"/>
+          </a:p>
+        </p:txBody>
+      </p:sp>
+      <p:sp>
+        <p:nvSpPr>
+          <p:cNvPr id="11" name="Text 9"/>
+          <p:cNvSpPr/>
+          <p:nvPr/>
+        </p:nvSpPr>
+        <p:spPr>
+          <a:xfrm>
+            <a:off x="640080" y="2423160"/>
+            <a:ext cx="2194560" cy="2103120"/>
+          </a:xfrm>
+          <a:prstGeom prst="rect">
+            <a:avLst/>
+          </a:prstGeom>
+          <a:noFill/>
+          <a:ln/>
+        </p:spPr>
+        <p:txBody>
+          <a:bodyPr wrap="square" rtlCol="0" anchor="t"/>
+          <a:lstStyle/>
+          <a:p>
+            <a:pPr indent="0" marL="0">
+              <a:buNone/>
+            </a:pPr>
+            <a:r>
+              <a:rPr lang="en-US" sz="1000" dirty="0">
                 <a:solidFill>
                   <a:srgbClr val="FFFFFF"/>
                 </a:solidFill>
@@ -2590,22 +2728,22 @@
                 <a:ea typeface="Open Sans" pitchFamily="34" charset="-122"/>
                 <a:cs typeface="Open Sans" pitchFamily="34" charset="-120"/>
               </a:rPr>
-              <a:t>Feed principal onde o conteúdo científico é compartilhado com balões de reflexão (baseados em Paulo Freire), quizzes interativos, modo foco e narração.</a:t>
-            </a:r>
-            <a:endParaRPr lang="en-US" sz="1200" dirty="0"/>
-          </a:p>
-        </p:txBody>
-      </p:sp>
-      <p:sp>
-        <p:nvSpPr>
-          <p:cNvPr id="11" name="Shape 9"/>
-          <p:cNvSpPr/>
-          <p:nvPr/>
-        </p:nvSpPr>
-        <p:spPr>
-          <a:xfrm>
-            <a:off x="4297680" y="1828800"/>
-            <a:ext cx="3291840" cy="4389120"/>
+              <a:t>Feed principal onde o conteúdo científico é compartilhado com base teórica em "Extensão ou Comunicação?" de Paulo Freire, quizzes interativos, modo foco e narração em áudio.</a:t>
+            </a:r>
+            <a:endParaRPr lang="en-US" sz="1000" dirty="0"/>
+          </a:p>
+        </p:txBody>
+      </p:sp>
+      <p:sp>
+        <p:nvSpPr>
+          <p:cNvPr id="12" name="Shape 10"/>
+          <p:cNvSpPr/>
+          <p:nvPr/>
+        </p:nvSpPr>
+        <p:spPr>
+          <a:xfrm>
+            <a:off x="3291840" y="1508760"/>
+            <a:ext cx="2560320" cy="3154680"/>
           </a:xfrm>
           <a:prstGeom prst="roundRect">
             <a:avLst/>
@@ -2613,7 +2751,7 @@
           <a:solidFill>
             <a:srgbClr val="1E1E1E"/>
           </a:solidFill>
-          <a:ln w="25400">
+          <a:ln w="19050">
             <a:solidFill>
               <a:srgbClr val="38BDF8"/>
             </a:solidFill>
@@ -2623,14 +2761,14 @@
       </p:sp>
       <p:sp>
         <p:nvSpPr>
-          <p:cNvPr id="12" name="Text 10"/>
-          <p:cNvSpPr/>
-          <p:nvPr/>
-        </p:nvSpPr>
-        <p:spPr>
-          <a:xfrm>
-            <a:off x="4572000" y="2103120"/>
-            <a:ext cx="2743200" cy="548640"/>
+          <p:cNvPr id="13" name="Text 11"/>
+          <p:cNvSpPr/>
+          <p:nvPr/>
+        </p:nvSpPr>
+        <p:spPr>
+          <a:xfrm>
+            <a:off x="3474720" y="1645920"/>
+            <a:ext cx="2194560" cy="365760"/>
           </a:xfrm>
           <a:prstGeom prst="rect">
             <a:avLst/>
@@ -2646,7 +2784,7 @@
               <a:buNone/>
             </a:pPr>
             <a:r>
-              <a:rPr lang="en-US" sz="1600" b="1" dirty="0">
+              <a:rPr lang="en-US" sz="1200" b="1" dirty="0">
                 <a:solidFill>
                   <a:srgbClr val="FFFFFF"/>
                 </a:solidFill>
@@ -2656,20 +2794,20 @@
               </a:rPr>
               <a:t>2. Logs</a:t>
             </a:r>
-            <a:endParaRPr lang="en-US" sz="1600" dirty="0"/>
-          </a:p>
-        </p:txBody>
-      </p:sp>
-      <p:sp>
-        <p:nvSpPr>
-          <p:cNvPr id="13" name="Text 11"/>
-          <p:cNvSpPr/>
-          <p:nvPr/>
-        </p:nvSpPr>
-        <p:spPr>
-          <a:xfrm>
-            <a:off x="4572000" y="2743200"/>
-            <a:ext cx="2743200" cy="365760"/>
+            <a:endParaRPr lang="en-US" sz="1200" dirty="0"/>
+          </a:p>
+        </p:txBody>
+      </p:sp>
+      <p:sp>
+        <p:nvSpPr>
+          <p:cNvPr id="14" name="Text 12"/>
+          <p:cNvSpPr/>
+          <p:nvPr/>
+        </p:nvSpPr>
+        <p:spPr>
+          <a:xfrm>
+            <a:off x="3474720" y="2057400"/>
+            <a:ext cx="2194560" cy="274320"/>
           </a:xfrm>
           <a:prstGeom prst="rect">
             <a:avLst/>
@@ -2685,7 +2823,7 @@
               <a:buNone/>
             </a:pPr>
             <a:r>
-              <a:rPr lang="en-US" sz="1000" b="1" dirty="0">
+              <a:rPr lang="en-US" sz="850" b="1" dirty="0">
                 <a:solidFill>
                   <a:srgbClr val="38BDF8"/>
                 </a:solidFill>
@@ -2695,36 +2833,36 @@
               </a:rPr>
               <a:t>VIVÊNCIA DISCENTE</a:t>
             </a:r>
-            <a:endParaRPr lang="en-US" sz="1000" dirty="0"/>
-          </a:p>
-        </p:txBody>
-      </p:sp>
-      <p:sp>
-        <p:nvSpPr>
-          <p:cNvPr id="14" name="Text 12"/>
-          <p:cNvSpPr/>
-          <p:nvPr/>
-        </p:nvSpPr>
-        <p:spPr>
-          <a:xfrm>
-            <a:off x="4572000" y="3291840"/>
-            <a:ext cx="2743200" cy="2560320"/>
-          </a:xfrm>
-          <a:prstGeom prst="rect">
-            <a:avLst/>
-          </a:prstGeom>
-          <a:noFill/>
-          <a:ln/>
-        </p:spPr>
-        <p:txBody>
-          <a:bodyPr wrap="square" rtlCol="0" anchor="ctr"/>
-          <a:lstStyle/>
-          <a:p>
-            <a:pPr indent="0" marL="0">
-              <a:buNone/>
-            </a:pPr>
-            <a:r>
-              <a:rPr lang="en-US" sz="1200" dirty="0">
+            <a:endParaRPr lang="en-US" sz="850" dirty="0"/>
+          </a:p>
+        </p:txBody>
+      </p:sp>
+      <p:sp>
+        <p:nvSpPr>
+          <p:cNvPr id="15" name="Text 13"/>
+          <p:cNvSpPr/>
+          <p:nvPr/>
+        </p:nvSpPr>
+        <p:spPr>
+          <a:xfrm>
+            <a:off x="3474720" y="2423160"/>
+            <a:ext cx="2194560" cy="2103120"/>
+          </a:xfrm>
+          <a:prstGeom prst="rect">
+            <a:avLst/>
+          </a:prstGeom>
+          <a:noFill/>
+          <a:ln/>
+        </p:spPr>
+        <p:txBody>
+          <a:bodyPr wrap="square" rtlCol="0" anchor="t"/>
+          <a:lstStyle/>
+          <a:p>
+            <a:pPr indent="0" marL="0">
+              <a:buNone/>
+            </a:pPr>
+            <a:r>
+              <a:rPr lang="en-US" sz="1000" dirty="0">
                 <a:solidFill>
                   <a:srgbClr val="FFFFFF"/>
                 </a:solidFill>
@@ -2734,20 +2872,20 @@
               </a:rPr>
               <a:t>Espaço humanizado para diários de vivência acadêmica, trocas cotidianas e desabafos entre alunos com sistema de fios energizados que conectam a comunidade.</a:t>
             </a:r>
-            <a:endParaRPr lang="en-US" sz="1200" dirty="0"/>
-          </a:p>
-        </p:txBody>
-      </p:sp>
-      <p:sp>
-        <p:nvSpPr>
-          <p:cNvPr id="15" name="Shape 13"/>
-          <p:cNvSpPr/>
-          <p:nvPr/>
-        </p:nvSpPr>
-        <p:spPr>
-          <a:xfrm>
-            <a:off x="7863840" y="1828800"/>
-            <a:ext cx="3291840" cy="4389120"/>
+            <a:endParaRPr lang="en-US" sz="1000" dirty="0"/>
+          </a:p>
+        </p:txBody>
+      </p:sp>
+      <p:sp>
+        <p:nvSpPr>
+          <p:cNvPr id="16" name="Shape 14"/>
+          <p:cNvSpPr/>
+          <p:nvPr/>
+        </p:nvSpPr>
+        <p:spPr>
+          <a:xfrm>
+            <a:off x="6126480" y="1508760"/>
+            <a:ext cx="2560320" cy="3154680"/>
           </a:xfrm>
           <a:prstGeom prst="roundRect">
             <a:avLst/>
@@ -2755,7 +2893,7 @@
           <a:solidFill>
             <a:srgbClr val="1E1E1E"/>
           </a:solidFill>
-          <a:ln w="25400">
+          <a:ln w="19050">
             <a:solidFill>
               <a:srgbClr val="F14343"/>
             </a:solidFill>
@@ -2765,14 +2903,14 @@
       </p:sp>
       <p:sp>
         <p:nvSpPr>
-          <p:cNvPr id="16" name="Text 14"/>
-          <p:cNvSpPr/>
-          <p:nvPr/>
-        </p:nvSpPr>
-        <p:spPr>
-          <a:xfrm>
-            <a:off x="8138160" y="2103120"/>
-            <a:ext cx="2743200" cy="548640"/>
+          <p:cNvPr id="17" name="Text 15"/>
+          <p:cNvSpPr/>
+          <p:nvPr/>
+        </p:nvSpPr>
+        <p:spPr>
+          <a:xfrm>
+            <a:off x="6309360" y="1645920"/>
+            <a:ext cx="2194560" cy="365760"/>
           </a:xfrm>
           <a:prstGeom prst="rect">
             <a:avLst/>
@@ -2788,7 +2926,7 @@
               <a:buNone/>
             </a:pPr>
             <a:r>
-              <a:rPr lang="en-US" sz="1600" b="1" dirty="0">
+              <a:rPr lang="en-US" sz="1200" b="1" dirty="0">
                 <a:solidFill>
                   <a:srgbClr val="FFFFFF"/>
                 </a:solidFill>
@@ -2798,20 +2936,20 @@
               </a:rPr>
               <a:t>3. Arte</a:t>
             </a:r>
-            <a:endParaRPr lang="en-US" sz="1600" dirty="0"/>
-          </a:p>
-        </p:txBody>
-      </p:sp>
-      <p:sp>
-        <p:nvSpPr>
-          <p:cNvPr id="17" name="Text 15"/>
-          <p:cNvSpPr/>
-          <p:nvPr/>
-        </p:nvSpPr>
-        <p:spPr>
-          <a:xfrm>
-            <a:off x="8138160" y="2743200"/>
-            <a:ext cx="2743200" cy="365760"/>
+            <a:endParaRPr lang="en-US" sz="1200" dirty="0"/>
+          </a:p>
+        </p:txBody>
+      </p:sp>
+      <p:sp>
+        <p:nvSpPr>
+          <p:cNvPr id="18" name="Text 16"/>
+          <p:cNvSpPr/>
+          <p:nvPr/>
+        </p:nvSpPr>
+        <p:spPr>
+          <a:xfrm>
+            <a:off x="6309360" y="2057400"/>
+            <a:ext cx="2194560" cy="274320"/>
           </a:xfrm>
           <a:prstGeom prst="rect">
             <a:avLst/>
@@ -2827,7 +2965,7 @@
               <a:buNone/>
             </a:pPr>
             <a:r>
-              <a:rPr lang="en-US" sz="1000" b="1" dirty="0">
+              <a:rPr lang="en-US" sz="850" b="1" dirty="0">
                 <a:solidFill>
                   <a:srgbClr val="F14343"/>
                 </a:solidFill>
@@ -2837,36 +2975,36 @@
               </a:rPr>
               <a:t>EXPRESSÃO ARTÍSTICA</a:t>
             </a:r>
-            <a:endParaRPr lang="en-US" sz="1000" dirty="0"/>
-          </a:p>
-        </p:txBody>
-      </p:sp>
-      <p:sp>
-        <p:nvSpPr>
-          <p:cNvPr id="18" name="Text 16"/>
-          <p:cNvSpPr/>
-          <p:nvPr/>
-        </p:nvSpPr>
-        <p:spPr>
-          <a:xfrm>
-            <a:off x="8138160" y="3291840"/>
-            <a:ext cx="2743200" cy="2560320"/>
-          </a:xfrm>
-          <a:prstGeom prst="rect">
-            <a:avLst/>
-          </a:prstGeom>
-          <a:noFill/>
-          <a:ln/>
-        </p:spPr>
-        <p:txBody>
-          <a:bodyPr wrap="square" rtlCol="0" anchor="ctr"/>
-          <a:lstStyle/>
-          <a:p>
-            <a:pPr indent="0" marL="0">
-              <a:buNone/>
-            </a:pPr>
-            <a:r>
-              <a:rPr lang="en-US" sz="1200" dirty="0">
+            <a:endParaRPr lang="en-US" sz="850" dirty="0"/>
+          </a:p>
+        </p:txBody>
+      </p:sp>
+      <p:sp>
+        <p:nvSpPr>
+          <p:cNvPr id="19" name="Text 17"/>
+          <p:cNvSpPr/>
+          <p:nvPr/>
+        </p:nvSpPr>
+        <p:spPr>
+          <a:xfrm>
+            <a:off x="6309360" y="2423160"/>
+            <a:ext cx="2194560" cy="2103120"/>
+          </a:xfrm>
+          <a:prstGeom prst="rect">
+            <a:avLst/>
+          </a:prstGeom>
+          <a:noFill/>
+          <a:ln/>
+        </p:spPr>
+        <p:txBody>
+          <a:bodyPr wrap="square" rtlCol="0" anchor="t"/>
+          <a:lstStyle/>
+          <a:p>
+            <a:pPr indent="0" marL="0">
+              <a:buNone/>
+            </a:pPr>
+            <a:r>
+              <a:rPr lang="en-US" sz="1000" dirty="0">
                 <a:solidFill>
                   <a:srgbClr val="FFFFFF"/>
                 </a:solidFill>
@@ -2876,7 +3014,7 @@
               </a:rPr>
               <a:t>Galeria autoral de expressão visual, fotográfica e poética integrada à ciência, transformando registros e percepções em manifestações artísticas.</a:t>
             </a:r>
-            <a:endParaRPr lang="en-US" sz="1200" dirty="0"/>
+            <a:endParaRPr lang="en-US" sz="1000" dirty="0"/>
           </a:p>
         </p:txBody>
       </p:sp>
@@ -2893,9 +3031,16 @@
   <p:cSld name="Slide 4">
     <p:bg>
       <p:bgPr>
-        <a:solidFill>
-          <a:srgbClr val="09090B"/>
-        </a:solidFill>
+        <a:blipFill dpi="0" rotWithShape="1">
+          <a:blip r:embed="rId1">
+            <a:lum/>
+          </a:blip>
+          <a:srcRect/>
+          <a:stretch>
+            <a:fillRect/>
+          </a:stretch>
+        </a:blipFill>
+        <a:effectLst/>
       </p:bgPr>
     </p:bg>
     <p:spTree>
@@ -2921,7 +3066,7 @@
         <p:spPr>
           <a:xfrm>
             <a:off x="0" y="0"/>
-            <a:ext cx="3044952" cy="91440"/>
+            <a:ext cx="3044952" cy="73152"/>
           </a:xfrm>
           <a:prstGeom prst="rect">
             <a:avLst/>
@@ -2941,7 +3086,7 @@
         <p:spPr>
           <a:xfrm>
             <a:off x="3044952" y="0"/>
-            <a:ext cx="3044952" cy="91440"/>
+            <a:ext cx="3044952" cy="73152"/>
           </a:xfrm>
           <a:prstGeom prst="rect">
             <a:avLst/>
@@ -2961,7 +3106,7 @@
         <p:spPr>
           <a:xfrm>
             <a:off x="6089904" y="0"/>
-            <a:ext cx="3054096" cy="91440"/>
+            <a:ext cx="3054096" cy="73152"/>
           </a:xfrm>
           <a:prstGeom prst="rect">
             <a:avLst/>
@@ -2980,8 +3125,8 @@
         </p:nvSpPr>
         <p:spPr>
           <a:xfrm>
-            <a:off x="731520" y="457200"/>
-            <a:ext cx="7315200" cy="365760"/>
+            <a:off x="457200" y="228600"/>
+            <a:ext cx="8229600" cy="274320"/>
           </a:xfrm>
           <a:prstGeom prst="rect">
             <a:avLst/>
@@ -2997,7 +3142,7 @@
               <a:buNone/>
             </a:pPr>
             <a:r>
-              <a:rPr lang="en-US" sz="1100" b="1" dirty="0">
+              <a:rPr lang="en-US" sz="900" b="1" dirty="0">
                 <a:solidFill>
                   <a:srgbClr val="38BDF8"/>
                 </a:solidFill>
@@ -3007,7 +3152,7 @@
               </a:rPr>
               <a:t>EIXO 2 — CGIF | HUB LABDIV</a:t>
             </a:r>
-            <a:endParaRPr lang="en-US" sz="1100" dirty="0"/>
+            <a:endParaRPr lang="en-US" sz="900" dirty="0"/>
           </a:p>
         </p:txBody>
       </p:sp>
@@ -3019,8 +3164,8 @@
         </p:nvSpPr>
         <p:spPr>
           <a:xfrm>
-            <a:off x="731520" y="822960"/>
-            <a:ext cx="10515600" cy="731520"/>
+            <a:off x="457200" y="502920"/>
+            <a:ext cx="8229600" cy="502920"/>
           </a:xfrm>
           <a:prstGeom prst="rect">
             <a:avLst/>
@@ -3036,7 +3181,7 @@
               <a:buNone/>
             </a:pPr>
             <a:r>
-              <a:rPr lang="en-US" sz="2400" b="1" dirty="0">
+              <a:rPr lang="en-US" sz="1800" b="1" dirty="0">
                 <a:solidFill>
                   <a:srgbClr val="FFFFFF"/>
                 </a:solidFill>
@@ -3046,20 +3191,59 @@
               </a:rPr>
               <a:t>Aba CGIF: Acesso à Informação &amp; Wiki Institucional</a:t>
             </a:r>
-            <a:endParaRPr lang="en-US" sz="2400" dirty="0"/>
-          </a:p>
-        </p:txBody>
-      </p:sp>
-      <p:sp>
-        <p:nvSpPr>
-          <p:cNvPr id="7" name="Shape 5"/>
-          <p:cNvSpPr/>
-          <p:nvPr/>
-        </p:nvSpPr>
-        <p:spPr>
-          <a:xfrm>
-            <a:off x="731520" y="2011680"/>
-            <a:ext cx="4937760" cy="1828800"/>
+            <a:endParaRPr lang="en-US" sz="1800" dirty="0"/>
+          </a:p>
+        </p:txBody>
+      </p:sp>
+      <p:sp>
+        <p:nvSpPr>
+          <p:cNvPr id="7" name="Text 5"/>
+          <p:cNvSpPr/>
+          <p:nvPr/>
+        </p:nvSpPr>
+        <p:spPr>
+          <a:xfrm>
+            <a:off x="457200" y="1051560"/>
+            <a:ext cx="8229600" cy="320040"/>
+          </a:xfrm>
+          <a:prstGeom prst="rect">
+            <a:avLst/>
+          </a:prstGeom>
+          <a:noFill/>
+          <a:ln/>
+        </p:spPr>
+        <p:txBody>
+          <a:bodyPr wrap="square" rtlCol="0" anchor="ctr"/>
+          <a:lstStyle/>
+          <a:p>
+            <a:pPr indent="0" marL="0">
+              <a:buNone/>
+            </a:pPr>
+            <a:r>
+              <a:rPr lang="en-US" sz="1100" b="1" dirty="0">
+                <a:solidFill>
+                  <a:srgbClr val="38BDF8"/>
+                </a:solidFill>
+                <a:latin typeface="Open Sans" pitchFamily="34" charset="0"/>
+                <a:ea typeface="Open Sans" pitchFamily="34" charset="-122"/>
+                <a:cs typeface="Open Sans" pitchFamily="34" charset="-120"/>
+              </a:rPr>
+              <a:t>Centralização do Conhecimento &amp; Memória do IFUSP</a:t>
+            </a:r>
+            <a:endParaRPr lang="en-US" sz="1100" dirty="0"/>
+          </a:p>
+        </p:txBody>
+      </p:sp>
+      <p:sp>
+        <p:nvSpPr>
+          <p:cNvPr id="8" name="Shape 6"/>
+          <p:cNvSpPr/>
+          <p:nvPr/>
+        </p:nvSpPr>
+        <p:spPr>
+          <a:xfrm>
+            <a:off x="457200" y="1508760"/>
+            <a:ext cx="4023360" cy="1417320"/>
           </a:xfrm>
           <a:prstGeom prst="roundRect">
             <a:avLst/>
@@ -3077,30 +3261,30 @@
       </p:sp>
       <p:sp>
         <p:nvSpPr>
-          <p:cNvPr id="8" name="Text 6"/>
-          <p:cNvSpPr/>
-          <p:nvPr/>
-        </p:nvSpPr>
-        <p:spPr>
-          <a:xfrm>
-            <a:off x="1005840" y="2194560"/>
-            <a:ext cx="4389120" cy="1463040"/>
-          </a:xfrm>
-          <a:prstGeom prst="rect">
-            <a:avLst/>
-          </a:prstGeom>
-          <a:noFill/>
-          <a:ln/>
-        </p:spPr>
-        <p:txBody>
-          <a:bodyPr wrap="square" rtlCol="0" anchor="ctr"/>
-          <a:lstStyle/>
-          <a:p>
-            <a:pPr indent="0" marL="0">
-              <a:buNone/>
-            </a:pPr>
-            <a:r>
-              <a:rPr lang="en-US" sz="1200" dirty="0">
+          <p:cNvPr id="9" name="Text 7"/>
+          <p:cNvSpPr/>
+          <p:nvPr/>
+        </p:nvSpPr>
+        <p:spPr>
+          <a:xfrm>
+            <a:off x="640080" y="1645920"/>
+            <a:ext cx="3657600" cy="1143000"/>
+          </a:xfrm>
+          <a:prstGeom prst="rect">
+            <a:avLst/>
+          </a:prstGeom>
+          <a:noFill/>
+          <a:ln/>
+        </p:spPr>
+        <p:txBody>
+          <a:bodyPr wrap="square" rtlCol="0" anchor="t"/>
+          <a:lstStyle/>
+          <a:p>
+            <a:pPr indent="0" marL="0">
+              <a:buNone/>
+            </a:pPr>
+            <a:r>
+              <a:rPr lang="en-US" sz="1050" dirty="0">
                 <a:solidFill>
                   <a:srgbClr val="FFFFFF"/>
                 </a:solidFill>
@@ -3110,20 +3294,20 @@
               </a:rPr>
               <a:t>Wiki CGIF: Manuais do curso, Projetos Político-Pedagógicos (PPPs), rotas de circulares e protocolos acadêmicos.</a:t>
             </a:r>
-            <a:endParaRPr lang="en-US" sz="1200" dirty="0"/>
-          </a:p>
-        </p:txBody>
-      </p:sp>
-      <p:sp>
-        <p:nvSpPr>
-          <p:cNvPr id="9" name="Shape 7"/>
-          <p:cNvSpPr/>
-          <p:nvPr/>
-        </p:nvSpPr>
-        <p:spPr>
-          <a:xfrm>
-            <a:off x="6035040" y="2011680"/>
-            <a:ext cx="4937760" cy="1828800"/>
+            <a:endParaRPr lang="en-US" sz="1050" dirty="0"/>
+          </a:p>
+        </p:txBody>
+      </p:sp>
+      <p:sp>
+        <p:nvSpPr>
+          <p:cNvPr id="10" name="Shape 8"/>
+          <p:cNvSpPr/>
+          <p:nvPr/>
+        </p:nvSpPr>
+        <p:spPr>
+          <a:xfrm>
+            <a:off x="4663440" y="1508760"/>
+            <a:ext cx="4023360" cy="1417320"/>
           </a:xfrm>
           <a:prstGeom prst="roundRect">
             <a:avLst/>
@@ -3141,30 +3325,30 @@
       </p:sp>
       <p:sp>
         <p:nvSpPr>
-          <p:cNvPr id="10" name="Text 8"/>
-          <p:cNvSpPr/>
-          <p:nvPr/>
-        </p:nvSpPr>
-        <p:spPr>
-          <a:xfrm>
-            <a:off x="6309360" y="2194560"/>
-            <a:ext cx="4389120" cy="1463040"/>
-          </a:xfrm>
-          <a:prstGeom prst="rect">
-            <a:avLst/>
-          </a:prstGeom>
-          <a:noFill/>
-          <a:ln/>
-        </p:spPr>
-        <p:txBody>
-          <a:bodyPr wrap="square" rtlCol="0" anchor="ctr"/>
-          <a:lstStyle/>
-          <a:p>
-            <a:pPr indent="0" marL="0">
-              <a:buNone/>
-            </a:pPr>
-            <a:r>
-              <a:rPr lang="en-US" sz="1200" dirty="0">
+          <p:cNvPr id="11" name="Text 9"/>
+          <p:cNvSpPr/>
+          <p:nvPr/>
+        </p:nvSpPr>
+        <p:spPr>
+          <a:xfrm>
+            <a:off x="4846320" y="1645920"/>
+            <a:ext cx="3657600" cy="1143000"/>
+          </a:xfrm>
+          <a:prstGeom prst="rect">
+            <a:avLst/>
+          </a:prstGeom>
+          <a:noFill/>
+          <a:ln/>
+        </p:spPr>
+        <p:txBody>
+          <a:bodyPr wrap="square" rtlCol="0" anchor="t"/>
+          <a:lstStyle/>
+          <a:p>
+            <a:pPr indent="0" marL="0">
+              <a:buNone/>
+            </a:pPr>
+            <a:r>
+              <a:rPr lang="en-US" sz="1050" dirty="0">
                 <a:solidFill>
                   <a:srgbClr val="FFFFFF"/>
                 </a:solidFill>
@@ -3174,20 +3358,20 @@
               </a:rPr>
               <a:t>Oportunidades &amp; Iniciativas: Catálogo em tempo real de bolsas PUB, Iniciações Científicas, estágios e simpósios.</a:t>
             </a:r>
-            <a:endParaRPr lang="en-US" sz="1200" dirty="0"/>
-          </a:p>
-        </p:txBody>
-      </p:sp>
-      <p:sp>
-        <p:nvSpPr>
-          <p:cNvPr id="11" name="Shape 9"/>
-          <p:cNvSpPr/>
-          <p:nvPr/>
-        </p:nvSpPr>
-        <p:spPr>
-          <a:xfrm>
-            <a:off x="731520" y="4114800"/>
-            <a:ext cx="4937760" cy="1828800"/>
+            <a:endParaRPr lang="en-US" sz="1050" dirty="0"/>
+          </a:p>
+        </p:txBody>
+      </p:sp>
+      <p:sp>
+        <p:nvSpPr>
+          <p:cNvPr id="12" name="Shape 10"/>
+          <p:cNvSpPr/>
+          <p:nvPr/>
+        </p:nvSpPr>
+        <p:spPr>
+          <a:xfrm>
+            <a:off x="457200" y="3063240"/>
+            <a:ext cx="4023360" cy="1417320"/>
           </a:xfrm>
           <a:prstGeom prst="roundRect">
             <a:avLst/>
@@ -3205,30 +3389,30 @@
       </p:sp>
       <p:sp>
         <p:nvSpPr>
-          <p:cNvPr id="12" name="Text 10"/>
-          <p:cNvSpPr/>
-          <p:nvPr/>
-        </p:nvSpPr>
-        <p:spPr>
-          <a:xfrm>
-            <a:off x="1005840" y="4297680"/>
-            <a:ext cx="4389120" cy="1463040"/>
-          </a:xfrm>
-          <a:prstGeom prst="rect">
-            <a:avLst/>
-          </a:prstGeom>
-          <a:noFill/>
-          <a:ln/>
-        </p:spPr>
-        <p:txBody>
-          <a:bodyPr wrap="square" rtlCol="0" anchor="ctr"/>
-          <a:lstStyle/>
-          <a:p>
-            <a:pPr indent="0" marL="0">
-              <a:buNone/>
-            </a:pPr>
-            <a:r>
-              <a:rPr lang="en-US" sz="1200" dirty="0">
+          <p:cNvPr id="13" name="Text 11"/>
+          <p:cNvSpPr/>
+          <p:nvPr/>
+        </p:nvSpPr>
+        <p:spPr>
+          <a:xfrm>
+            <a:off x="640080" y="3200400"/>
+            <a:ext cx="3657600" cy="1143000"/>
+          </a:xfrm>
+          <a:prstGeom prst="rect">
+            <a:avLst/>
+          </a:prstGeom>
+          <a:noFill/>
+          <a:ln/>
+        </p:spPr>
+        <p:txBody>
+          <a:bodyPr wrap="square" rtlCol="0" anchor="t"/>
+          <a:lstStyle/>
+          <a:p>
+            <a:pPr indent="0" marL="0">
+              <a:buNone/>
+            </a:pPr>
+            <a:r>
+              <a:rPr lang="en-US" sz="1050" dirty="0">
                 <a:solidFill>
                   <a:srgbClr val="FFFFFF"/>
                 </a:solidFill>
@@ -3238,20 +3422,20 @@
               </a:rPr>
               <a:t>Espaços &amp; Mapa Interativo: Conexão direta dos laboratórios físicos do IFUSP via leitura de QR Codes.</a:t>
             </a:r>
-            <a:endParaRPr lang="en-US" sz="1200" dirty="0"/>
-          </a:p>
-        </p:txBody>
-      </p:sp>
-      <p:sp>
-        <p:nvSpPr>
-          <p:cNvPr id="13" name="Shape 11"/>
-          <p:cNvSpPr/>
-          <p:nvPr/>
-        </p:nvSpPr>
-        <p:spPr>
-          <a:xfrm>
-            <a:off x="6035040" y="4114800"/>
-            <a:ext cx="4937760" cy="1828800"/>
+            <a:endParaRPr lang="en-US" sz="1050" dirty="0"/>
+          </a:p>
+        </p:txBody>
+      </p:sp>
+      <p:sp>
+        <p:nvSpPr>
+          <p:cNvPr id="14" name="Shape 12"/>
+          <p:cNvSpPr/>
+          <p:nvPr/>
+        </p:nvSpPr>
+        <p:spPr>
+          <a:xfrm>
+            <a:off x="4663440" y="3063240"/>
+            <a:ext cx="4023360" cy="1417320"/>
           </a:xfrm>
           <a:prstGeom prst="roundRect">
             <a:avLst/>
@@ -3269,30 +3453,30 @@
       </p:sp>
       <p:sp>
         <p:nvSpPr>
-          <p:cNvPr id="14" name="Text 12"/>
-          <p:cNvSpPr/>
-          <p:nvPr/>
-        </p:nvSpPr>
-        <p:spPr>
-          <a:xfrm>
-            <a:off x="6309360" y="4297680"/>
-            <a:ext cx="4389120" cy="1463040"/>
-          </a:xfrm>
-          <a:prstGeom prst="rect">
-            <a:avLst/>
-          </a:prstGeom>
-          <a:noFill/>
-          <a:ln/>
-        </p:spPr>
-        <p:txBody>
-          <a:bodyPr wrap="square" rtlCol="0" anchor="ctr"/>
-          <a:lstStyle/>
-          <a:p>
-            <a:pPr indent="0" marL="0">
-              <a:buNone/>
-            </a:pPr>
-            <a:r>
-              <a:rPr lang="en-US" sz="1200" dirty="0">
+          <p:cNvPr id="15" name="Text 13"/>
+          <p:cNvSpPr/>
+          <p:nvPr/>
+        </p:nvSpPr>
+        <p:spPr>
+          <a:xfrm>
+            <a:off x="4846320" y="3200400"/>
+            <a:ext cx="3657600" cy="1143000"/>
+          </a:xfrm>
+          <a:prstGeom prst="rect">
+            <a:avLst/>
+          </a:prstGeom>
+          <a:noFill/>
+          <a:ln/>
+        </p:spPr>
+        <p:txBody>
+          <a:bodyPr wrap="square" rtlCol="0" anchor="t"/>
+          <a:lstStyle/>
+          <a:p>
+            <a:pPr indent="0" marL="0">
+              <a:buNone/>
+            </a:pPr>
+            <a:r>
+              <a:rPr lang="en-US" sz="1050" dirty="0">
                 <a:solidFill>
                   <a:srgbClr val="FFFFFF"/>
                 </a:solidFill>
@@ -3302,7 +3486,7 @@
               </a:rPr>
               <a:t>Influenciadores &amp; Teste de Radiação: Divulgação de criadores do IFUSP e quiz interativo de fixação da Wiki.</a:t>
             </a:r>
-            <a:endParaRPr lang="en-US" sz="1200" dirty="0"/>
+            <a:endParaRPr lang="en-US" sz="1050" dirty="0"/>
           </a:p>
         </p:txBody>
       </p:sp>
@@ -3319,9 +3503,16 @@
   <p:cSld name="Slide 5">
     <p:bg>
       <p:bgPr>
-        <a:solidFill>
-          <a:srgbClr val="09090B"/>
-        </a:solidFill>
+        <a:blipFill dpi="0" rotWithShape="1">
+          <a:blip r:embed="rId1">
+            <a:lum/>
+          </a:blip>
+          <a:srcRect/>
+          <a:stretch>
+            <a:fillRect/>
+          </a:stretch>
+        </a:blipFill>
+        <a:effectLst/>
       </p:bgPr>
     </p:bg>
     <p:spTree>
@@ -3347,7 +3538,7 @@
         <p:spPr>
           <a:xfrm>
             <a:off x="0" y="0"/>
-            <a:ext cx="3044952" cy="91440"/>
+            <a:ext cx="3044952" cy="73152"/>
           </a:xfrm>
           <a:prstGeom prst="rect">
             <a:avLst/>
@@ -3367,7 +3558,7 @@
         <p:spPr>
           <a:xfrm>
             <a:off x="3044952" y="0"/>
-            <a:ext cx="3044952" cy="91440"/>
+            <a:ext cx="3044952" cy="73152"/>
           </a:xfrm>
           <a:prstGeom prst="rect">
             <a:avLst/>
@@ -3387,7 +3578,7 @@
         <p:spPr>
           <a:xfrm>
             <a:off x="6089904" y="0"/>
-            <a:ext cx="3054096" cy="91440"/>
+            <a:ext cx="3054096" cy="73152"/>
           </a:xfrm>
           <a:prstGeom prst="rect">
             <a:avLst/>
@@ -3406,8 +3597,8 @@
         </p:nvSpPr>
         <p:spPr>
           <a:xfrm>
-            <a:off x="731520" y="457200"/>
-            <a:ext cx="7315200" cy="365760"/>
+            <a:off x="457200" y="228600"/>
+            <a:ext cx="8229600" cy="274320"/>
           </a:xfrm>
           <a:prstGeom prst="rect">
             <a:avLst/>
@@ -3423,7 +3614,7 @@
               <a:buNone/>
             </a:pPr>
             <a:r>
-              <a:rPr lang="en-US" sz="1100" b="1" dirty="0">
+              <a:rPr lang="en-US" sz="900" b="1" dirty="0">
                 <a:solidFill>
                   <a:srgbClr val="F14343"/>
                 </a:solidFill>
@@ -3433,7 +3624,7 @@
               </a:rPr>
               <a:t>EIXO 3 — FERRAMENTAS | HUB LABDIV</a:t>
             </a:r>
-            <a:endParaRPr lang="en-US" sz="1100" dirty="0"/>
+            <a:endParaRPr lang="en-US" sz="900" dirty="0"/>
           </a:p>
         </p:txBody>
       </p:sp>
@@ -3445,8 +3636,8 @@
         </p:nvSpPr>
         <p:spPr>
           <a:xfrm>
-            <a:off x="731520" y="822960"/>
-            <a:ext cx="10515600" cy="731520"/>
+            <a:off x="457200" y="502920"/>
+            <a:ext cx="8229600" cy="502920"/>
           </a:xfrm>
           <a:prstGeom prst="rect">
             <a:avLst/>
@@ -3462,7 +3653,7 @@
               <a:buNone/>
             </a:pPr>
             <a:r>
-              <a:rPr lang="en-US" sz="2400" b="1" dirty="0">
+              <a:rPr lang="en-US" sz="1800" b="1" dirty="0">
                 <a:solidFill>
                   <a:srgbClr val="FFFFFF"/>
                 </a:solidFill>
@@ -3472,20 +3663,59 @@
               </a:rPr>
               <a:t>Aba Ferramentas: Apoio ao Estudo &amp; Pesquisa</a:t>
             </a:r>
-            <a:endParaRPr lang="en-US" sz="2400" dirty="0"/>
-          </a:p>
-        </p:txBody>
-      </p:sp>
-      <p:sp>
-        <p:nvSpPr>
-          <p:cNvPr id="7" name="Shape 5"/>
-          <p:cNvSpPr/>
-          <p:nvPr/>
-        </p:nvSpPr>
-        <p:spPr>
-          <a:xfrm>
-            <a:off x="731520" y="2011680"/>
-            <a:ext cx="4937760" cy="1828800"/>
+            <a:endParaRPr lang="en-US" sz="1800" dirty="0"/>
+          </a:p>
+        </p:txBody>
+      </p:sp>
+      <p:sp>
+        <p:nvSpPr>
+          <p:cNvPr id="7" name="Text 5"/>
+          <p:cNvSpPr/>
+          <p:nvPr/>
+        </p:nvSpPr>
+        <p:spPr>
+          <a:xfrm>
+            <a:off x="457200" y="1051560"/>
+            <a:ext cx="8229600" cy="320040"/>
+          </a:xfrm>
+          <a:prstGeom prst="rect">
+            <a:avLst/>
+          </a:prstGeom>
+          <a:noFill/>
+          <a:ln/>
+        </p:spPr>
+        <p:txBody>
+          <a:bodyPr wrap="square" rtlCol="0" anchor="ctr"/>
+          <a:lstStyle/>
+          <a:p>
+            <a:pPr indent="0" marL="0">
+              <a:buNone/>
+            </a:pPr>
+            <a:r>
+              <a:rPr lang="en-US" sz="1100" b="1" dirty="0">
+                <a:solidFill>
+                  <a:srgbClr val="F14343"/>
+                </a:solidFill>
+                <a:latin typeface="Open Sans" pitchFamily="34" charset="0"/>
+                <a:ea typeface="Open Sans" pitchFamily="34" charset="-122"/>
+                <a:cs typeface="Open Sans" pitchFamily="34" charset="-120"/>
+              </a:rPr>
+              <a:t>Produtividade acadêmica, retenção discente e aproximação com pesquisadores</a:t>
+            </a:r>
+            <a:endParaRPr lang="en-US" sz="1100" dirty="0"/>
+          </a:p>
+        </p:txBody>
+      </p:sp>
+      <p:sp>
+        <p:nvSpPr>
+          <p:cNvPr id="8" name="Shape 6"/>
+          <p:cNvSpPr/>
+          <p:nvPr/>
+        </p:nvSpPr>
+        <p:spPr>
+          <a:xfrm>
+            <a:off x="457200" y="1508760"/>
+            <a:ext cx="4023360" cy="1417320"/>
           </a:xfrm>
           <a:prstGeom prst="roundRect">
             <a:avLst/>
@@ -3503,30 +3733,30 @@
       </p:sp>
       <p:sp>
         <p:nvSpPr>
-          <p:cNvPr id="8" name="Text 6"/>
-          <p:cNvSpPr/>
-          <p:nvPr/>
-        </p:nvSpPr>
-        <p:spPr>
-          <a:xfrm>
-            <a:off x="1005840" y="2194560"/>
-            <a:ext cx="4389120" cy="1463040"/>
-          </a:xfrm>
-          <a:prstGeom prst="rect">
-            <a:avLst/>
-          </a:prstGeom>
-          <a:noFill/>
-          <a:ln/>
-        </p:spPr>
-        <p:txBody>
-          <a:bodyPr wrap="square" rtlCol="0" anchor="ctr"/>
-          <a:lstStyle/>
-          <a:p>
-            <a:pPr indent="0" marL="0">
-              <a:buNone/>
-            </a:pPr>
-            <a:r>
-              <a:rPr lang="en-US" sz="1200" dirty="0">
+          <p:cNvPr id="9" name="Text 7"/>
+          <p:cNvSpPr/>
+          <p:nvPr/>
+        </p:nvSpPr>
+        <p:spPr>
+          <a:xfrm>
+            <a:off x="640080" y="1645920"/>
+            <a:ext cx="3657600" cy="1143000"/>
+          </a:xfrm>
+          <a:prstGeom prst="rect">
+            <a:avLst/>
+          </a:prstGeom>
+          <a:noFill/>
+          <a:ln/>
+        </p:spPr>
+        <p:txBody>
+          <a:bodyPr wrap="square" rtlCol="0" anchor="t"/>
+          <a:lstStyle/>
+          <a:p>
+            <a:pPr indent="0" marL="0">
+              <a:buNone/>
+            </a:pPr>
+            <a:r>
+              <a:rPr lang="en-US" sz="1050" dirty="0">
                 <a:solidFill>
                   <a:srgbClr val="FFFFFF"/>
                 </a:solidFill>
@@ -3536,20 +3766,20 @@
               </a:rPr>
               <a:t>Grade Horária (1h:1h): Planejador semanal de estudos que associa 1 hora de aula a 1 hora de estudo individual.</a:t>
             </a:r>
-            <a:endParaRPr lang="en-US" sz="1200" dirty="0"/>
-          </a:p>
-        </p:txBody>
-      </p:sp>
-      <p:sp>
-        <p:nvSpPr>
-          <p:cNvPr id="9" name="Shape 7"/>
-          <p:cNvSpPr/>
-          <p:nvPr/>
-        </p:nvSpPr>
-        <p:spPr>
-          <a:xfrm>
-            <a:off x="6035040" y="2011680"/>
-            <a:ext cx="4937760" cy="1828800"/>
+            <a:endParaRPr lang="en-US" sz="1050" dirty="0"/>
+          </a:p>
+        </p:txBody>
+      </p:sp>
+      <p:sp>
+        <p:nvSpPr>
+          <p:cNvPr id="10" name="Shape 8"/>
+          <p:cNvSpPr/>
+          <p:nvPr/>
+        </p:nvSpPr>
+        <p:spPr>
+          <a:xfrm>
+            <a:off x="4663440" y="1508760"/>
+            <a:ext cx="4023360" cy="1417320"/>
           </a:xfrm>
           <a:prstGeom prst="roundRect">
             <a:avLst/>
@@ -3567,30 +3797,30 @@
       </p:sp>
       <p:sp>
         <p:nvSpPr>
-          <p:cNvPr id="10" name="Text 8"/>
-          <p:cNvSpPr/>
-          <p:nvPr/>
-        </p:nvSpPr>
-        <p:spPr>
-          <a:xfrm>
-            <a:off x="6309360" y="2194560"/>
-            <a:ext cx="4389120" cy="1463040"/>
-          </a:xfrm>
-          <a:prstGeom prst="rect">
-            <a:avLst/>
-          </a:prstGeom>
-          <a:noFill/>
-          <a:ln/>
-        </p:spPr>
-        <p:txBody>
-          <a:bodyPr wrap="square" rtlCol="0" anchor="ctr"/>
-          <a:lstStyle/>
-          <a:p>
-            <a:pPr indent="0" marL="0">
-              <a:buNone/>
-            </a:pPr>
-            <a:r>
-              <a:rPr lang="en-US" sz="1200" dirty="0">
+          <p:cNvPr id="11" name="Text 9"/>
+          <p:cNvSpPr/>
+          <p:nvPr/>
+        </p:nvSpPr>
+        <p:spPr>
+          <a:xfrm>
+            <a:off x="4846320" y="1645920"/>
+            <a:ext cx="3657600" cy="1143000"/>
+          </a:xfrm>
+          <a:prstGeom prst="rect">
+            <a:avLst/>
+          </a:prstGeom>
+          <a:noFill/>
+          <a:ln/>
+        </p:spPr>
+        <p:txBody>
+          <a:bodyPr wrap="square" rtlCol="0" anchor="t"/>
+          <a:lstStyle/>
+          <a:p>
+            <a:pPr indent="0" marL="0">
+              <a:buNone/>
+            </a:pPr>
+            <a:r>
+              <a:rPr lang="en-US" sz="1050" dirty="0">
                 <a:solidFill>
                   <a:srgbClr val="FFFFFF"/>
                 </a:solidFill>
@@ -3600,20 +3830,20 @@
               </a:rPr>
               <a:t>Trilhas do Curso: Acompanhamento de disciplinas cursadas, pendências e pré-requisitos com sincronização.</a:t>
             </a:r>
-            <a:endParaRPr lang="en-US" sz="1200" dirty="0"/>
-          </a:p>
-        </p:txBody>
-      </p:sp>
-      <p:sp>
-        <p:nvSpPr>
-          <p:cNvPr id="11" name="Shape 9"/>
-          <p:cNvSpPr/>
-          <p:nvPr/>
-        </p:nvSpPr>
-        <p:spPr>
-          <a:xfrm>
-            <a:off x="731520" y="4114800"/>
-            <a:ext cx="4937760" cy="1828800"/>
+            <a:endParaRPr lang="en-US" sz="1050" dirty="0"/>
+          </a:p>
+        </p:txBody>
+      </p:sp>
+      <p:sp>
+        <p:nvSpPr>
+          <p:cNvPr id="12" name="Shape 10"/>
+          <p:cNvSpPr/>
+          <p:nvPr/>
+        </p:nvSpPr>
+        <p:spPr>
+          <a:xfrm>
+            <a:off x="457200" y="3063240"/>
+            <a:ext cx="4023360" cy="1417320"/>
           </a:xfrm>
           <a:prstGeom prst="roundRect">
             <a:avLst/>
@@ -3631,30 +3861,30 @@
       </p:sp>
       <p:sp>
         <p:nvSpPr>
-          <p:cNvPr id="12" name="Text 10"/>
-          <p:cNvSpPr/>
-          <p:nvPr/>
-        </p:nvSpPr>
-        <p:spPr>
-          <a:xfrm>
-            <a:off x="1005840" y="4297680"/>
-            <a:ext cx="4389120" cy="1463040"/>
-          </a:xfrm>
-          <a:prstGeom prst="rect">
-            <a:avLst/>
-          </a:prstGeom>
-          <a:noFill/>
-          <a:ln/>
-        </p:spPr>
-        <p:txBody>
-          <a:bodyPr wrap="square" rtlCol="0" anchor="ctr"/>
-          <a:lstStyle/>
-          <a:p>
-            <a:pPr indent="0" marL="0">
-              <a:buNone/>
-            </a:pPr>
-            <a:r>
-              <a:rPr lang="en-US" sz="1200" dirty="0">
+          <p:cNvPr id="13" name="Text 11"/>
+          <p:cNvSpPr/>
+          <p:nvPr/>
+        </p:nvSpPr>
+        <p:spPr>
+          <a:xfrm>
+            <a:off x="640080" y="3200400"/>
+            <a:ext cx="3657600" cy="1143000"/>
+          </a:xfrm>
+          <a:prstGeom prst="rect">
+            <a:avLst/>
+          </a:prstGeom>
+          <a:noFill/>
+          <a:ln/>
+        </p:spPr>
+        <p:txBody>
+          <a:bodyPr wrap="square" rtlCol="0" anchor="t"/>
+          <a:lstStyle/>
+          <a:p>
+            <a:pPr indent="0" marL="0">
+              <a:buNone/>
+            </a:pPr>
+            <a:r>
+              <a:rPr lang="en-US" sz="1050" dirty="0">
                 <a:solidFill>
                   <a:srgbClr val="FFFFFF"/>
                 </a:solidFill>
@@ -3664,20 +3894,20 @@
               </a:rPr>
               <a:t>Match Acadêmico ("Quero uma IC"): Aproximação entre cartas de interesse de alunos e linhas de pesquisa do IFUSP.</a:t>
             </a:r>
-            <a:endParaRPr lang="en-US" sz="1200" dirty="0"/>
-          </a:p>
-        </p:txBody>
-      </p:sp>
-      <p:sp>
-        <p:nvSpPr>
-          <p:cNvPr id="13" name="Shape 11"/>
-          <p:cNvSpPr/>
-          <p:nvPr/>
-        </p:nvSpPr>
-        <p:spPr>
-          <a:xfrm>
-            <a:off x="6035040" y="4114800"/>
-            <a:ext cx="4937760" cy="1828800"/>
+            <a:endParaRPr lang="en-US" sz="1050" dirty="0"/>
+          </a:p>
+        </p:txBody>
+      </p:sp>
+      <p:sp>
+        <p:nvSpPr>
+          <p:cNvPr id="14" name="Shape 12"/>
+          <p:cNvSpPr/>
+          <p:nvPr/>
+        </p:nvSpPr>
+        <p:spPr>
+          <a:xfrm>
+            <a:off x="4663440" y="3063240"/>
+            <a:ext cx="4023360" cy="1417320"/>
           </a:xfrm>
           <a:prstGeom prst="roundRect">
             <a:avLst/>
@@ -3695,30 +3925,30 @@
       </p:sp>
       <p:sp>
         <p:nvSpPr>
-          <p:cNvPr id="14" name="Text 12"/>
-          <p:cNvSpPr/>
-          <p:nvPr/>
-        </p:nvSpPr>
-        <p:spPr>
-          <a:xfrm>
-            <a:off x="6309360" y="4297680"/>
-            <a:ext cx="4389120" cy="1463040"/>
-          </a:xfrm>
-          <a:prstGeom prst="rect">
-            <a:avLst/>
-          </a:prstGeom>
-          <a:noFill/>
-          <a:ln/>
-        </p:spPr>
-        <p:txBody>
-          <a:bodyPr wrap="square" rtlCol="0" anchor="ctr"/>
-          <a:lstStyle/>
-          <a:p>
-            <a:pPr indent="0" marL="0">
-              <a:buNone/>
-            </a:pPr>
-            <a:r>
-              <a:rPr lang="en-US" sz="1200" dirty="0">
+          <p:cNvPr id="15" name="Text 13"/>
+          <p:cNvSpPr/>
+          <p:nvPr/>
+        </p:nvSpPr>
+        <p:spPr>
+          <a:xfrm>
+            <a:off x="4846320" y="3200400"/>
+            <a:ext cx="3657600" cy="1143000"/>
+          </a:xfrm>
+          <a:prstGeom prst="rect">
+            <a:avLst/>
+          </a:prstGeom>
+          <a:noFill/>
+          <a:ln/>
+        </p:spPr>
+        <p:txBody>
+          <a:bodyPr wrap="square" rtlCol="0" anchor="t"/>
+          <a:lstStyle/>
+          <a:p>
+            <a:pPr indent="0" marL="0">
+              <a:buNone/>
+            </a:pPr>
+            <a:r>
+              <a:rPr lang="en-US" sz="1050" dirty="0">
                 <a:solidFill>
                   <a:srgbClr val="FFFFFF"/>
                 </a:solidFill>
@@ -3728,7 +3958,7 @@
               </a:rPr>
               <a:t>Como Ingressar &amp; Observatório: Guia para vestibulandos, apoio à permanência e arena dos pesquisadores.</a:t>
             </a:r>
-            <a:endParaRPr lang="en-US" sz="1200" dirty="0"/>
+            <a:endParaRPr lang="en-US" sz="1050" dirty="0"/>
           </a:p>
         </p:txBody>
       </p:sp>

</xml_diff>